<commit_message>
Chart AIS base information on a second slide
Plots the four AIS Base Information dimensions - charge type, tenure,
nano-loan flag and TRUE ecosystem - as percent-stacked bars split by
DL and PL, matching the cash-need and risk chart on slide 1.

Counts are aggregated across all book dates; each breakdown sums to
70,100, matching the stated AIS consortium count.

Co-Authored-By: Claude Opus 5 <noreply@anthropic.com>
Claude-Session: https://claude.ai/code/session_01VKpfo226Go9vQJYa4eoC1d
</commit_message>
<xml_diff>
--- a/Lending_Book_Loan_Summary.pptx
+++ b/Lending_Book_Loan_Summary.pptx
@@ -6,9 +6,10 @@
   </p:sldMasterIdLst>
   <p:sldIdLst>
     <p:sldId id="256" r:id="rId2"/>
+    <p:sldId id="257" r:id="rId3"/>
   </p:sldIdLst>
   <p:notesMasterIdLst>
-    <p:notesMasterId r:id="rId3"/>
+    <p:notesMasterId r:id="rId4"/>
   </p:notesMasterIdLst>
   <p:sldSz cx="12192000" cy="6858000"/>
   <p:notesSz cx="6858000" cy="12192000"/>
@@ -663,6 +664,1570 @@
 </c:chartSpace>
 </file>
 
+<file path=ppt/charts/chart2.xml><?xml version="1.0" encoding="utf-8"?>
+<c:chartSpace xmlns:c="http://schemas.openxmlformats.org/drawingml/2006/chart" xmlns:a="http://schemas.openxmlformats.org/drawingml/2006/main" xmlns:r="http://schemas.openxmlformats.org/officeDocument/2006/relationships">
+  <c:date1904 val="0"/>
+  <c:roundedCorners val="1"/>
+  <c:chart>
+    <c:title>
+      <c:tx>
+        <c:rich>
+          <a:bodyPr/>
+          <a:lstStyle/>
+          <a:p>
+            <a:pPr>
+              <a:defRPr sz="1200" b="0" i="0" u="none" strike="noStrike">
+                <a:solidFill>
+                  <a:srgbClr val="16233D"/>
+                </a:solidFill>
+                <a:latin typeface="Calibri"/>
+              </a:defRPr>
+            </a:pPr>
+            <a:r>
+              <a:rPr sz="1200" b="0" i="0" u="none" strike="noStrike">
+                <a:solidFill>
+                  <a:srgbClr val="16233D"/>
+                </a:solidFill>
+                <a:latin typeface="Calibri"/>
+              </a:rPr>
+              <a:t>Charge type (% of customers)</a:t>
+            </a:r>
+          </a:p>
+        </c:rich>
+      </c:tx>
+      <c:layout/>
+      <c:overlay val="0"/>
+    </c:title>
+    <c:autoTitleDeleted val="0"/>
+    <c:plotArea>
+      <c:layout/>
+      <c:barChart>
+        <c:barDir val="bar"/>
+        <c:grouping val="percentStacked"/>
+        <c:varyColors val="0"/>
+        <c:ser>
+          <c:idx val="0"/>
+          <c:order val="0"/>
+          <c:tx>
+            <c:strRef>
+              <c:f>Sheet1!$B$1</c:f>
+              <c:strCache>
+                <c:ptCount val="1"/>
+                <c:pt idx="0">
+                  <c:v>FBB</c:v>
+                </c:pt>
+              </c:strCache>
+            </c:strRef>
+          </c:tx>
+          <c:spPr>
+            <a:solidFill>
+              <a:srgbClr val="3FB89F"/>
+            </a:solidFill>
+            <a:effectLst/>
+          </c:spPr>
+          <c:invertIfNegative val="0"/>
+          <c:dLbls>
+            <c:numFmt formatCode="0.0&quot;%&quot;" sourceLinked="0"/>
+            <c:txPr>
+              <a:bodyPr/>
+              <a:lstStyle/>
+              <a:p>
+                <a:pPr>
+                  <a:defRPr b="0" i="0" strike="noStrike" sz="950" u="none">
+                    <a:solidFill>
+                      <a:srgbClr val="FFFFFF"/>
+                    </a:solidFill>
+                    <a:latin typeface="Calibri"/>
+                  </a:defRPr>
+                </a:pPr>
+              </a:p>
+            </c:txPr>
+            <c:dLblPos val="ctr"/>
+            <c:showLegendKey val="0"/>
+            <c:showVal val="1"/>
+            <c:showCatName val="0"/>
+            <c:showSerName val="0"/>
+            <c:showPercent val="0"/>
+            <c:showBubbleSize val="0"/>
+            <c:showLeaderLines val="0"/>
+          </c:dLbls>
+          <c:cat>
+            <c:multiLvlStrRef>
+              <c:f>Sheet1!$A$2:$A$3</c:f>
+              <c:multiLvlStrCache>
+                <c:ptCount val="2"/>
+                <c:lvl>
+                  <c:pt idx="0">
+                    <c:v>DL</c:v>
+                  </c:pt>
+                  <c:pt idx="1">
+                    <c:v>PL</c:v>
+                  </c:pt>
+                </c:lvl>
+              </c:multiLvlStrCache>
+            </c:multiLvlStrRef>
+          </c:cat>
+          <c:val>
+            <c:numRef>
+              <c:f>Sheet1!$B$2:$B$3</c:f>
+              <c:numCache>
+                <c:formatCode>General</c:formatCode>
+                <c:ptCount val="2"/>
+                <c:pt idx="0">
+                  <c:v>6.5</c:v>
+                </c:pt>
+                <c:pt idx="1">
+                  <c:v>6.2</c:v>
+                </c:pt>
+              </c:numCache>
+            </c:numRef>
+          </c:val>
+        </c:ser>
+        <c:ser>
+          <c:idx val="1"/>
+          <c:order val="1"/>
+          <c:tx>
+            <c:strRef>
+              <c:f>Sheet1!$C$1</c:f>
+              <c:strCache>
+                <c:ptCount val="1"/>
+                <c:pt idx="0">
+                  <c:v>Prepaid</c:v>
+                </c:pt>
+              </c:strCache>
+            </c:strRef>
+          </c:tx>
+          <c:spPr>
+            <a:solidFill>
+              <a:srgbClr val="1E8E86"/>
+            </a:solidFill>
+            <a:effectLst/>
+          </c:spPr>
+          <c:invertIfNegative val="0"/>
+          <c:dLbls>
+            <c:numFmt formatCode="0.0&quot;%&quot;" sourceLinked="0"/>
+            <c:txPr>
+              <a:bodyPr/>
+              <a:lstStyle/>
+              <a:p>
+                <a:pPr>
+                  <a:defRPr b="0" i="0" strike="noStrike" sz="950" u="none">
+                    <a:solidFill>
+                      <a:srgbClr val="FFFFFF"/>
+                    </a:solidFill>
+                    <a:latin typeface="Calibri"/>
+                  </a:defRPr>
+                </a:pPr>
+              </a:p>
+            </c:txPr>
+            <c:dLblPos val="ctr"/>
+            <c:showLegendKey val="0"/>
+            <c:showVal val="1"/>
+            <c:showCatName val="0"/>
+            <c:showSerName val="0"/>
+            <c:showPercent val="0"/>
+            <c:showBubbleSize val="0"/>
+            <c:showLeaderLines val="0"/>
+          </c:dLbls>
+          <c:cat>
+            <c:multiLvlStrRef>
+              <c:f>Sheet1!$A$2:$A$3</c:f>
+              <c:multiLvlStrCache>
+                <c:ptCount val="2"/>
+                <c:lvl>
+                  <c:pt idx="0">
+                    <c:v>DL</c:v>
+                  </c:pt>
+                  <c:pt idx="1">
+                    <c:v>PL</c:v>
+                  </c:pt>
+                </c:lvl>
+              </c:multiLvlStrCache>
+            </c:multiLvlStrRef>
+          </c:cat>
+          <c:val>
+            <c:numRef>
+              <c:f>Sheet1!$C$2:$C$3</c:f>
+              <c:numCache>
+                <c:formatCode>General</c:formatCode>
+                <c:ptCount val="2"/>
+                <c:pt idx="0">
+                  <c:v>48.8</c:v>
+                </c:pt>
+                <c:pt idx="1">
+                  <c:v>56</c:v>
+                </c:pt>
+              </c:numCache>
+            </c:numRef>
+          </c:val>
+        </c:ser>
+        <c:ser>
+          <c:idx val="2"/>
+          <c:order val="2"/>
+          <c:tx>
+            <c:strRef>
+              <c:f>Sheet1!$D$1</c:f>
+              <c:strCache>
+                <c:ptCount val="1"/>
+                <c:pt idx="0">
+                  <c:v>Postpaid</c:v>
+                </c:pt>
+              </c:strCache>
+            </c:strRef>
+          </c:tx>
+          <c:spPr>
+            <a:solidFill>
+              <a:srgbClr val="165A73"/>
+            </a:solidFill>
+            <a:effectLst/>
+          </c:spPr>
+          <c:invertIfNegative val="0"/>
+          <c:dLbls>
+            <c:numFmt formatCode="0.0&quot;%&quot;" sourceLinked="0"/>
+            <c:txPr>
+              <a:bodyPr/>
+              <a:lstStyle/>
+              <a:p>
+                <a:pPr>
+                  <a:defRPr b="0" i="0" strike="noStrike" sz="950" u="none">
+                    <a:solidFill>
+                      <a:srgbClr val="FFFFFF"/>
+                    </a:solidFill>
+                    <a:latin typeface="Calibri"/>
+                  </a:defRPr>
+                </a:pPr>
+              </a:p>
+            </c:txPr>
+            <c:dLblPos val="ctr"/>
+            <c:showLegendKey val="0"/>
+            <c:showVal val="1"/>
+            <c:showCatName val="0"/>
+            <c:showSerName val="0"/>
+            <c:showPercent val="0"/>
+            <c:showBubbleSize val="0"/>
+            <c:showLeaderLines val="0"/>
+          </c:dLbls>
+          <c:cat>
+            <c:multiLvlStrRef>
+              <c:f>Sheet1!$A$2:$A$3</c:f>
+              <c:multiLvlStrCache>
+                <c:ptCount val="2"/>
+                <c:lvl>
+                  <c:pt idx="0">
+                    <c:v>DL</c:v>
+                  </c:pt>
+                  <c:pt idx="1">
+                    <c:v>PL</c:v>
+                  </c:pt>
+                </c:lvl>
+              </c:multiLvlStrCache>
+            </c:multiLvlStrRef>
+          </c:cat>
+          <c:val>
+            <c:numRef>
+              <c:f>Sheet1!$D$2:$D$3</c:f>
+              <c:numCache>
+                <c:formatCode>General</c:formatCode>
+                <c:ptCount val="2"/>
+                <c:pt idx="0">
+                  <c:v>44.7</c:v>
+                </c:pt>
+                <c:pt idx="1">
+                  <c:v>37.8</c:v>
+                </c:pt>
+              </c:numCache>
+            </c:numRef>
+          </c:val>
+        </c:ser>
+        <c:dLbls>
+          <c:numFmt formatCode="0.0&quot;%&quot;" sourceLinked="0"/>
+          <c:txPr>
+            <a:bodyPr/>
+            <a:lstStyle/>
+            <a:p>
+              <a:pPr>
+                <a:defRPr b="0" i="0" strike="noStrike" sz="950" u="none">
+                  <a:solidFill>
+                    <a:srgbClr val="FFFFFF"/>
+                  </a:solidFill>
+                  <a:latin typeface="Calibri"/>
+                </a:defRPr>
+              </a:pPr>
+            </a:p>
+          </c:txPr>
+          <c:dLblPos val="ctr"/>
+          <c:showLegendKey val="0"/>
+          <c:showVal val="1"/>
+          <c:showCatName val="0"/>
+          <c:showSerName val="0"/>
+          <c:showPercent val="0"/>
+          <c:showBubbleSize val="0"/>
+          <c:showLeaderLines val="0"/>
+        </c:dLbls>
+        <c:gapWidth val="45"/>
+        <c:overlap val="100"/>
+        <c:axId val="2094734554"/>
+        <c:axId val="2094734552"/>
+        <c:axId val="2094734556"/>
+      </c:barChart>
+      <c:catAx>
+        <c:axId val="2094734554"/>
+        <c:scaling>
+          <c:orientation val="minMax"/>
+        </c:scaling>
+        <c:delete val="0"/>
+        <c:axPos val="l"/>
+        <c:numFmt formatCode="General" sourceLinked="1"/>
+        <c:majorTickMark val="out"/>
+        <c:minorTickMark val="none"/>
+        <c:tickLblPos val="nextTo"/>
+        <c:spPr>
+          <a:ln w="12700" cap="flat">
+            <a:solidFill>
+              <a:srgbClr val="888888"/>
+            </a:solidFill>
+            <a:prstDash val="solid"/>
+            <a:round/>
+          </a:ln>
+        </c:spPr>
+        <c:txPr>
+          <a:bodyPr/>
+          <a:lstStyle/>
+          <a:p>
+            <a:pPr>
+              <a:defRPr sz="1100" b="0" i="0" u="none" strike="noStrike">
+                <a:solidFill>
+                  <a:srgbClr val="16233D"/>
+                </a:solidFill>
+                <a:latin typeface="Calibri"/>
+              </a:defRPr>
+            </a:pPr>
+            <a:endParaRPr lang="en-US"/>
+          </a:p>
+        </c:txPr>
+        <c:crossAx val="2094734552"/>
+        <c:crosses val="autoZero"/>
+        <c:auto val="1"/>
+        <c:lblAlgn val="ctr"/>
+        <c:noMultiLvlLbl val="1"/>
+      </c:catAx>
+      <c:valAx>
+        <c:axId val="2094734552"/>
+        <c:scaling>
+          <c:orientation val="minMax"/>
+        </c:scaling>
+        <c:delete val="1"/>
+        <c:axPos val="b"/>
+        <c:numFmt formatCode="General" sourceLinked="0"/>
+        <c:majorTickMark val="out"/>
+        <c:minorTickMark val="none"/>
+        <c:tickLblPos val="low"/>
+        <c:spPr>
+          <a:ln w="12700" cap="flat">
+            <a:solidFill>
+              <a:srgbClr val="888888"/>
+            </a:solidFill>
+            <a:prstDash val="solid"/>
+            <a:round/>
+          </a:ln>
+        </c:spPr>
+        <c:txPr>
+          <a:bodyPr/>
+          <a:lstStyle/>
+          <a:p>
+            <a:pPr>
+              <a:defRPr sz="1200" b="0" i="0" u="none" strike="noStrike">
+                <a:solidFill>
+                  <a:srgbClr val="000000"/>
+                </a:solidFill>
+                <a:latin typeface="Arial"/>
+              </a:defRPr>
+            </a:pPr>
+            <a:endParaRPr lang="en-US"/>
+          </a:p>
+        </c:txPr>
+        <c:crossAx val="2094734554"/>
+        <c:crosses val="autoZero"/>
+        <c:crossBetween val="between"/>
+      </c:valAx>
+      <c:spPr>
+        <a:noFill/>
+        <a:ln>
+          <a:noFill/>
+        </a:ln>
+        <a:effectLst/>
+      </c:spPr>
+    </c:plotArea>
+    <c:legend>
+      <c:legendPos val="b"/>
+      <c:overlay val="0"/>
+      <c:txPr>
+        <a:bodyPr/>
+        <a:lstStyle/>
+        <a:p>
+          <a:pPr>
+            <a:defRPr sz="1000">
+              <a:solidFill>
+                <a:srgbClr val="16233D"/>
+              </a:solidFill>
+              <a:latin typeface="Calibri"/>
+              <a:cs typeface="Calibri"/>
+            </a:defRPr>
+          </a:pPr>
+          <a:endParaRPr lang="en-US"/>
+        </a:p>
+      </c:txPr>
+    </c:legend>
+    <c:plotVisOnly val="1"/>
+    <c:dispBlanksAs val="span"/>
+  </c:chart>
+  <c:spPr>
+    <a:noFill/>
+    <a:ln>
+      <a:noFill/>
+    </a:ln>
+    <a:effectLst/>
+  </c:spPr>
+  <c:externalData r:id="rId1">
+    <c:autoUpdate val="0"/>
+  </c:externalData>
+</c:chartSpace>
+</file>
+
+<file path=ppt/charts/chart3.xml><?xml version="1.0" encoding="utf-8"?>
+<c:chartSpace xmlns:c="http://schemas.openxmlformats.org/drawingml/2006/chart" xmlns:a="http://schemas.openxmlformats.org/drawingml/2006/main" xmlns:r="http://schemas.openxmlformats.org/officeDocument/2006/relationships">
+  <c:date1904 val="0"/>
+  <c:roundedCorners val="1"/>
+  <c:chart>
+    <c:title>
+      <c:tx>
+        <c:rich>
+          <a:bodyPr/>
+          <a:lstStyle/>
+          <a:p>
+            <a:pPr>
+              <a:defRPr sz="1200" b="0" i="0" u="none" strike="noStrike">
+                <a:solidFill>
+                  <a:srgbClr val="16233D"/>
+                </a:solidFill>
+                <a:latin typeface="Calibri"/>
+              </a:defRPr>
+            </a:pPr>
+            <a:r>
+              <a:rPr sz="1200" b="0" i="0" u="none" strike="noStrike">
+                <a:solidFill>
+                  <a:srgbClr val="16233D"/>
+                </a:solidFill>
+                <a:latin typeface="Calibri"/>
+              </a:rPr>
+              <a:t>Tenure in years (% of customers)</a:t>
+            </a:r>
+          </a:p>
+        </c:rich>
+      </c:tx>
+      <c:layout/>
+      <c:overlay val="0"/>
+    </c:title>
+    <c:autoTitleDeleted val="0"/>
+    <c:plotArea>
+      <c:layout/>
+      <c:barChart>
+        <c:barDir val="bar"/>
+        <c:grouping val="percentStacked"/>
+        <c:varyColors val="0"/>
+        <c:ser>
+          <c:idx val="0"/>
+          <c:order val="0"/>
+          <c:tx>
+            <c:strRef>
+              <c:f>Sheet1!$B$1</c:f>
+              <c:strCache>
+                <c:ptCount val="1"/>
+                <c:pt idx="0">
+                  <c:v>0–1</c:v>
+                </c:pt>
+              </c:strCache>
+            </c:strRef>
+          </c:tx>
+          <c:spPr>
+            <a:solidFill>
+              <a:srgbClr val="3FB89F"/>
+            </a:solidFill>
+            <a:effectLst/>
+          </c:spPr>
+          <c:invertIfNegative val="0"/>
+          <c:dLbls>
+            <c:numFmt formatCode="0.0&quot;%&quot;" sourceLinked="0"/>
+            <c:txPr>
+              <a:bodyPr/>
+              <a:lstStyle/>
+              <a:p>
+                <a:pPr>
+                  <a:defRPr b="0" i="0" strike="noStrike" sz="950" u="none">
+                    <a:solidFill>
+                      <a:srgbClr val="FFFFFF"/>
+                    </a:solidFill>
+                    <a:latin typeface="Calibri"/>
+                  </a:defRPr>
+                </a:pPr>
+              </a:p>
+            </c:txPr>
+            <c:dLblPos val="ctr"/>
+            <c:showLegendKey val="0"/>
+            <c:showVal val="1"/>
+            <c:showCatName val="0"/>
+            <c:showSerName val="0"/>
+            <c:showPercent val="0"/>
+            <c:showBubbleSize val="0"/>
+            <c:showLeaderLines val="0"/>
+          </c:dLbls>
+          <c:cat>
+            <c:multiLvlStrRef>
+              <c:f>Sheet1!$A$2:$A$3</c:f>
+              <c:multiLvlStrCache>
+                <c:ptCount val="2"/>
+                <c:lvl>
+                  <c:pt idx="0">
+                    <c:v>DL</c:v>
+                  </c:pt>
+                  <c:pt idx="1">
+                    <c:v>PL</c:v>
+                  </c:pt>
+                </c:lvl>
+              </c:multiLvlStrCache>
+            </c:multiLvlStrRef>
+          </c:cat>
+          <c:val>
+            <c:numRef>
+              <c:f>Sheet1!$B$2:$B$3</c:f>
+              <c:numCache>
+                <c:formatCode>General</c:formatCode>
+                <c:ptCount val="2"/>
+                <c:pt idx="0">
+                  <c:v>11</c:v>
+                </c:pt>
+                <c:pt idx="1">
+                  <c:v>10.8</c:v>
+                </c:pt>
+              </c:numCache>
+            </c:numRef>
+          </c:val>
+        </c:ser>
+        <c:ser>
+          <c:idx val="1"/>
+          <c:order val="1"/>
+          <c:tx>
+            <c:strRef>
+              <c:f>Sheet1!$C$1</c:f>
+              <c:strCache>
+                <c:ptCount val="1"/>
+                <c:pt idx="0">
+                  <c:v>2–4</c:v>
+                </c:pt>
+              </c:strCache>
+            </c:strRef>
+          </c:tx>
+          <c:spPr>
+            <a:solidFill>
+              <a:srgbClr val="1E8E86"/>
+            </a:solidFill>
+            <a:effectLst/>
+          </c:spPr>
+          <c:invertIfNegative val="0"/>
+          <c:dLbls>
+            <c:numFmt formatCode="0.0&quot;%&quot;" sourceLinked="0"/>
+            <c:txPr>
+              <a:bodyPr/>
+              <a:lstStyle/>
+              <a:p>
+                <a:pPr>
+                  <a:defRPr b="0" i="0" strike="noStrike" sz="950" u="none">
+                    <a:solidFill>
+                      <a:srgbClr val="FFFFFF"/>
+                    </a:solidFill>
+                    <a:latin typeface="Calibri"/>
+                  </a:defRPr>
+                </a:pPr>
+              </a:p>
+            </c:txPr>
+            <c:dLblPos val="ctr"/>
+            <c:showLegendKey val="0"/>
+            <c:showVal val="1"/>
+            <c:showCatName val="0"/>
+            <c:showSerName val="0"/>
+            <c:showPercent val="0"/>
+            <c:showBubbleSize val="0"/>
+            <c:showLeaderLines val="0"/>
+          </c:dLbls>
+          <c:cat>
+            <c:multiLvlStrRef>
+              <c:f>Sheet1!$A$2:$A$3</c:f>
+              <c:multiLvlStrCache>
+                <c:ptCount val="2"/>
+                <c:lvl>
+                  <c:pt idx="0">
+                    <c:v>DL</c:v>
+                  </c:pt>
+                  <c:pt idx="1">
+                    <c:v>PL</c:v>
+                  </c:pt>
+                </c:lvl>
+              </c:multiLvlStrCache>
+            </c:multiLvlStrRef>
+          </c:cat>
+          <c:val>
+            <c:numRef>
+              <c:f>Sheet1!$C$2:$C$3</c:f>
+              <c:numCache>
+                <c:formatCode>General</c:formatCode>
+                <c:ptCount val="2"/>
+                <c:pt idx="0">
+                  <c:v>22.7</c:v>
+                </c:pt>
+                <c:pt idx="1">
+                  <c:v>23.6</c:v>
+                </c:pt>
+              </c:numCache>
+            </c:numRef>
+          </c:val>
+        </c:ser>
+        <c:ser>
+          <c:idx val="2"/>
+          <c:order val="2"/>
+          <c:tx>
+            <c:strRef>
+              <c:f>Sheet1!$D$1</c:f>
+              <c:strCache>
+                <c:ptCount val="1"/>
+                <c:pt idx="0">
+                  <c:v>5 or more</c:v>
+                </c:pt>
+              </c:strCache>
+            </c:strRef>
+          </c:tx>
+          <c:spPr>
+            <a:solidFill>
+              <a:srgbClr val="165A73"/>
+            </a:solidFill>
+            <a:effectLst/>
+          </c:spPr>
+          <c:invertIfNegative val="0"/>
+          <c:dLbls>
+            <c:numFmt formatCode="0.0&quot;%&quot;" sourceLinked="0"/>
+            <c:txPr>
+              <a:bodyPr/>
+              <a:lstStyle/>
+              <a:p>
+                <a:pPr>
+                  <a:defRPr b="0" i="0" strike="noStrike" sz="950" u="none">
+                    <a:solidFill>
+                      <a:srgbClr val="FFFFFF"/>
+                    </a:solidFill>
+                    <a:latin typeface="Calibri"/>
+                  </a:defRPr>
+                </a:pPr>
+              </a:p>
+            </c:txPr>
+            <c:dLblPos val="ctr"/>
+            <c:showLegendKey val="0"/>
+            <c:showVal val="1"/>
+            <c:showCatName val="0"/>
+            <c:showSerName val="0"/>
+            <c:showPercent val="0"/>
+            <c:showBubbleSize val="0"/>
+            <c:showLeaderLines val="0"/>
+          </c:dLbls>
+          <c:cat>
+            <c:multiLvlStrRef>
+              <c:f>Sheet1!$A$2:$A$3</c:f>
+              <c:multiLvlStrCache>
+                <c:ptCount val="2"/>
+                <c:lvl>
+                  <c:pt idx="0">
+                    <c:v>DL</c:v>
+                  </c:pt>
+                  <c:pt idx="1">
+                    <c:v>PL</c:v>
+                  </c:pt>
+                </c:lvl>
+              </c:multiLvlStrCache>
+            </c:multiLvlStrRef>
+          </c:cat>
+          <c:val>
+            <c:numRef>
+              <c:f>Sheet1!$D$2:$D$3</c:f>
+              <c:numCache>
+                <c:formatCode>General</c:formatCode>
+                <c:ptCount val="2"/>
+                <c:pt idx="0">
+                  <c:v>66.3</c:v>
+                </c:pt>
+                <c:pt idx="1">
+                  <c:v>65.6</c:v>
+                </c:pt>
+              </c:numCache>
+            </c:numRef>
+          </c:val>
+        </c:ser>
+        <c:dLbls>
+          <c:numFmt formatCode="0.0&quot;%&quot;" sourceLinked="0"/>
+          <c:txPr>
+            <a:bodyPr/>
+            <a:lstStyle/>
+            <a:p>
+              <a:pPr>
+                <a:defRPr b="0" i="0" strike="noStrike" sz="950" u="none">
+                  <a:solidFill>
+                    <a:srgbClr val="FFFFFF"/>
+                  </a:solidFill>
+                  <a:latin typeface="Calibri"/>
+                </a:defRPr>
+              </a:pPr>
+            </a:p>
+          </c:txPr>
+          <c:dLblPos val="ctr"/>
+          <c:showLegendKey val="0"/>
+          <c:showVal val="1"/>
+          <c:showCatName val="0"/>
+          <c:showSerName val="0"/>
+          <c:showPercent val="0"/>
+          <c:showBubbleSize val="0"/>
+          <c:showLeaderLines val="0"/>
+        </c:dLbls>
+        <c:gapWidth val="45"/>
+        <c:overlap val="100"/>
+        <c:axId val="2094734554"/>
+        <c:axId val="2094734552"/>
+        <c:axId val="2094734556"/>
+      </c:barChart>
+      <c:catAx>
+        <c:axId val="2094734554"/>
+        <c:scaling>
+          <c:orientation val="minMax"/>
+        </c:scaling>
+        <c:delete val="0"/>
+        <c:axPos val="l"/>
+        <c:numFmt formatCode="General" sourceLinked="1"/>
+        <c:majorTickMark val="out"/>
+        <c:minorTickMark val="none"/>
+        <c:tickLblPos val="nextTo"/>
+        <c:spPr>
+          <a:ln w="12700" cap="flat">
+            <a:solidFill>
+              <a:srgbClr val="888888"/>
+            </a:solidFill>
+            <a:prstDash val="solid"/>
+            <a:round/>
+          </a:ln>
+        </c:spPr>
+        <c:txPr>
+          <a:bodyPr/>
+          <a:lstStyle/>
+          <a:p>
+            <a:pPr>
+              <a:defRPr sz="1100" b="0" i="0" u="none" strike="noStrike">
+                <a:solidFill>
+                  <a:srgbClr val="16233D"/>
+                </a:solidFill>
+                <a:latin typeface="Calibri"/>
+              </a:defRPr>
+            </a:pPr>
+            <a:endParaRPr lang="en-US"/>
+          </a:p>
+        </c:txPr>
+        <c:crossAx val="2094734552"/>
+        <c:crosses val="autoZero"/>
+        <c:auto val="1"/>
+        <c:lblAlgn val="ctr"/>
+        <c:noMultiLvlLbl val="1"/>
+      </c:catAx>
+      <c:valAx>
+        <c:axId val="2094734552"/>
+        <c:scaling>
+          <c:orientation val="minMax"/>
+        </c:scaling>
+        <c:delete val="1"/>
+        <c:axPos val="b"/>
+        <c:numFmt formatCode="General" sourceLinked="0"/>
+        <c:majorTickMark val="out"/>
+        <c:minorTickMark val="none"/>
+        <c:tickLblPos val="low"/>
+        <c:spPr>
+          <a:ln w="12700" cap="flat">
+            <a:solidFill>
+              <a:srgbClr val="888888"/>
+            </a:solidFill>
+            <a:prstDash val="solid"/>
+            <a:round/>
+          </a:ln>
+        </c:spPr>
+        <c:txPr>
+          <a:bodyPr/>
+          <a:lstStyle/>
+          <a:p>
+            <a:pPr>
+              <a:defRPr sz="1200" b="0" i="0" u="none" strike="noStrike">
+                <a:solidFill>
+                  <a:srgbClr val="000000"/>
+                </a:solidFill>
+                <a:latin typeface="Arial"/>
+              </a:defRPr>
+            </a:pPr>
+            <a:endParaRPr lang="en-US"/>
+          </a:p>
+        </c:txPr>
+        <c:crossAx val="2094734554"/>
+        <c:crosses val="autoZero"/>
+        <c:crossBetween val="between"/>
+      </c:valAx>
+      <c:spPr>
+        <a:noFill/>
+        <a:ln>
+          <a:noFill/>
+        </a:ln>
+        <a:effectLst/>
+      </c:spPr>
+    </c:plotArea>
+    <c:legend>
+      <c:legendPos val="b"/>
+      <c:overlay val="0"/>
+      <c:txPr>
+        <a:bodyPr/>
+        <a:lstStyle/>
+        <a:p>
+          <a:pPr>
+            <a:defRPr sz="1000">
+              <a:solidFill>
+                <a:srgbClr val="16233D"/>
+              </a:solidFill>
+              <a:latin typeface="Calibri"/>
+              <a:cs typeface="Calibri"/>
+            </a:defRPr>
+          </a:pPr>
+          <a:endParaRPr lang="en-US"/>
+        </a:p>
+      </c:txPr>
+    </c:legend>
+    <c:plotVisOnly val="1"/>
+    <c:dispBlanksAs val="span"/>
+  </c:chart>
+  <c:spPr>
+    <a:noFill/>
+    <a:ln>
+      <a:noFill/>
+    </a:ln>
+    <a:effectLst/>
+  </c:spPr>
+  <c:externalData r:id="rId1">
+    <c:autoUpdate val="0"/>
+  </c:externalData>
+</c:chartSpace>
+</file>
+
+<file path=ppt/charts/chart4.xml><?xml version="1.0" encoding="utf-8"?>
+<c:chartSpace xmlns:c="http://schemas.openxmlformats.org/drawingml/2006/chart" xmlns:a="http://schemas.openxmlformats.org/drawingml/2006/main" xmlns:r="http://schemas.openxmlformats.org/officeDocument/2006/relationships">
+  <c:date1904 val="0"/>
+  <c:roundedCorners val="1"/>
+  <c:chart>
+    <c:title>
+      <c:tx>
+        <c:rich>
+          <a:bodyPr/>
+          <a:lstStyle/>
+          <a:p>
+            <a:pPr>
+              <a:defRPr sz="1200" b="0" i="0" u="none" strike="noStrike">
+                <a:solidFill>
+                  <a:srgbClr val="16233D"/>
+                </a:solidFill>
+                <a:latin typeface="Calibri"/>
+              </a:defRPr>
+            </a:pPr>
+            <a:r>
+              <a:rPr sz="1200" b="0" i="0" u="none" strike="noStrike">
+                <a:solidFill>
+                  <a:srgbClr val="16233D"/>
+                </a:solidFill>
+                <a:latin typeface="Calibri"/>
+              </a:rPr>
+              <a:t>Nano-loan flag (% of customers)</a:t>
+            </a:r>
+          </a:p>
+        </c:rich>
+      </c:tx>
+      <c:layout/>
+      <c:overlay val="0"/>
+    </c:title>
+    <c:autoTitleDeleted val="0"/>
+    <c:plotArea>
+      <c:layout/>
+      <c:barChart>
+        <c:barDir val="bar"/>
+        <c:grouping val="percentStacked"/>
+        <c:varyColors val="0"/>
+        <c:ser>
+          <c:idx val="0"/>
+          <c:order val="0"/>
+          <c:tx>
+            <c:strRef>
+              <c:f>Sheet1!$B$1</c:f>
+              <c:strCache>
+                <c:ptCount val="1"/>
+                <c:pt idx="0">
+                  <c:v>N</c:v>
+                </c:pt>
+              </c:strCache>
+            </c:strRef>
+          </c:tx>
+          <c:spPr>
+            <a:solidFill>
+              <a:srgbClr val="8DA0B8"/>
+            </a:solidFill>
+            <a:effectLst/>
+          </c:spPr>
+          <c:invertIfNegative val="0"/>
+          <c:dLbls>
+            <c:numFmt formatCode="0.0&quot;%&quot;" sourceLinked="0"/>
+            <c:txPr>
+              <a:bodyPr/>
+              <a:lstStyle/>
+              <a:p>
+                <a:pPr>
+                  <a:defRPr b="0" i="0" strike="noStrike" sz="950" u="none">
+                    <a:solidFill>
+                      <a:srgbClr val="FFFFFF"/>
+                    </a:solidFill>
+                    <a:latin typeface="Calibri"/>
+                  </a:defRPr>
+                </a:pPr>
+              </a:p>
+            </c:txPr>
+            <c:dLblPos val="ctr"/>
+            <c:showLegendKey val="0"/>
+            <c:showVal val="1"/>
+            <c:showCatName val="0"/>
+            <c:showSerName val="0"/>
+            <c:showPercent val="0"/>
+            <c:showBubbleSize val="0"/>
+            <c:showLeaderLines val="0"/>
+          </c:dLbls>
+          <c:cat>
+            <c:multiLvlStrRef>
+              <c:f>Sheet1!$A$2:$A$3</c:f>
+              <c:multiLvlStrCache>
+                <c:ptCount val="2"/>
+                <c:lvl>
+                  <c:pt idx="0">
+                    <c:v>DL</c:v>
+                  </c:pt>
+                  <c:pt idx="1">
+                    <c:v>PL</c:v>
+                  </c:pt>
+                </c:lvl>
+              </c:multiLvlStrCache>
+            </c:multiLvlStrRef>
+          </c:cat>
+          <c:val>
+            <c:numRef>
+              <c:f>Sheet1!$B$2:$B$3</c:f>
+              <c:numCache>
+                <c:formatCode>General</c:formatCode>
+                <c:ptCount val="2"/>
+                <c:pt idx="0">
+                  <c:v>38.2</c:v>
+                </c:pt>
+                <c:pt idx="1">
+                  <c:v>46.2</c:v>
+                </c:pt>
+              </c:numCache>
+            </c:numRef>
+          </c:val>
+        </c:ser>
+        <c:ser>
+          <c:idx val="1"/>
+          <c:order val="1"/>
+          <c:tx>
+            <c:strRef>
+              <c:f>Sheet1!$C$1</c:f>
+              <c:strCache>
+                <c:ptCount val="1"/>
+                <c:pt idx="0">
+                  <c:v>Y</c:v>
+                </c:pt>
+              </c:strCache>
+            </c:strRef>
+          </c:tx>
+          <c:spPr>
+            <a:solidFill>
+              <a:srgbClr val="165A73"/>
+            </a:solidFill>
+            <a:effectLst/>
+          </c:spPr>
+          <c:invertIfNegative val="0"/>
+          <c:dLbls>
+            <c:numFmt formatCode="0.0&quot;%&quot;" sourceLinked="0"/>
+            <c:txPr>
+              <a:bodyPr/>
+              <a:lstStyle/>
+              <a:p>
+                <a:pPr>
+                  <a:defRPr b="0" i="0" strike="noStrike" sz="950" u="none">
+                    <a:solidFill>
+                      <a:srgbClr val="FFFFFF"/>
+                    </a:solidFill>
+                    <a:latin typeface="Calibri"/>
+                  </a:defRPr>
+                </a:pPr>
+              </a:p>
+            </c:txPr>
+            <c:dLblPos val="ctr"/>
+            <c:showLegendKey val="0"/>
+            <c:showVal val="1"/>
+            <c:showCatName val="0"/>
+            <c:showSerName val="0"/>
+            <c:showPercent val="0"/>
+            <c:showBubbleSize val="0"/>
+            <c:showLeaderLines val="0"/>
+          </c:dLbls>
+          <c:cat>
+            <c:multiLvlStrRef>
+              <c:f>Sheet1!$A$2:$A$3</c:f>
+              <c:multiLvlStrCache>
+                <c:ptCount val="2"/>
+                <c:lvl>
+                  <c:pt idx="0">
+                    <c:v>DL</c:v>
+                  </c:pt>
+                  <c:pt idx="1">
+                    <c:v>PL</c:v>
+                  </c:pt>
+                </c:lvl>
+              </c:multiLvlStrCache>
+            </c:multiLvlStrRef>
+          </c:cat>
+          <c:val>
+            <c:numRef>
+              <c:f>Sheet1!$C$2:$C$3</c:f>
+              <c:numCache>
+                <c:formatCode>General</c:formatCode>
+                <c:ptCount val="2"/>
+                <c:pt idx="0">
+                  <c:v>61.8</c:v>
+                </c:pt>
+                <c:pt idx="1">
+                  <c:v>53.8</c:v>
+                </c:pt>
+              </c:numCache>
+            </c:numRef>
+          </c:val>
+        </c:ser>
+        <c:dLbls>
+          <c:numFmt formatCode="0.0&quot;%&quot;" sourceLinked="0"/>
+          <c:txPr>
+            <a:bodyPr/>
+            <a:lstStyle/>
+            <a:p>
+              <a:pPr>
+                <a:defRPr b="0" i="0" strike="noStrike" sz="950" u="none">
+                  <a:solidFill>
+                    <a:srgbClr val="FFFFFF"/>
+                  </a:solidFill>
+                  <a:latin typeface="Calibri"/>
+                </a:defRPr>
+              </a:pPr>
+            </a:p>
+          </c:txPr>
+          <c:dLblPos val="ctr"/>
+          <c:showLegendKey val="0"/>
+          <c:showVal val="1"/>
+          <c:showCatName val="0"/>
+          <c:showSerName val="0"/>
+          <c:showPercent val="0"/>
+          <c:showBubbleSize val="0"/>
+          <c:showLeaderLines val="0"/>
+        </c:dLbls>
+        <c:gapWidth val="45"/>
+        <c:overlap val="100"/>
+        <c:axId val="2094734554"/>
+        <c:axId val="2094734552"/>
+        <c:axId val="2094734556"/>
+      </c:barChart>
+      <c:catAx>
+        <c:axId val="2094734554"/>
+        <c:scaling>
+          <c:orientation val="minMax"/>
+        </c:scaling>
+        <c:delete val="0"/>
+        <c:axPos val="l"/>
+        <c:numFmt formatCode="General" sourceLinked="1"/>
+        <c:majorTickMark val="out"/>
+        <c:minorTickMark val="none"/>
+        <c:tickLblPos val="nextTo"/>
+        <c:spPr>
+          <a:ln w="12700" cap="flat">
+            <a:solidFill>
+              <a:srgbClr val="888888"/>
+            </a:solidFill>
+            <a:prstDash val="solid"/>
+            <a:round/>
+          </a:ln>
+        </c:spPr>
+        <c:txPr>
+          <a:bodyPr/>
+          <a:lstStyle/>
+          <a:p>
+            <a:pPr>
+              <a:defRPr sz="1100" b="0" i="0" u="none" strike="noStrike">
+                <a:solidFill>
+                  <a:srgbClr val="16233D"/>
+                </a:solidFill>
+                <a:latin typeface="Calibri"/>
+              </a:defRPr>
+            </a:pPr>
+            <a:endParaRPr lang="en-US"/>
+          </a:p>
+        </c:txPr>
+        <c:crossAx val="2094734552"/>
+        <c:crosses val="autoZero"/>
+        <c:auto val="1"/>
+        <c:lblAlgn val="ctr"/>
+        <c:noMultiLvlLbl val="1"/>
+      </c:catAx>
+      <c:valAx>
+        <c:axId val="2094734552"/>
+        <c:scaling>
+          <c:orientation val="minMax"/>
+        </c:scaling>
+        <c:delete val="1"/>
+        <c:axPos val="b"/>
+        <c:numFmt formatCode="General" sourceLinked="0"/>
+        <c:majorTickMark val="out"/>
+        <c:minorTickMark val="none"/>
+        <c:tickLblPos val="low"/>
+        <c:spPr>
+          <a:ln w="12700" cap="flat">
+            <a:solidFill>
+              <a:srgbClr val="888888"/>
+            </a:solidFill>
+            <a:prstDash val="solid"/>
+            <a:round/>
+          </a:ln>
+        </c:spPr>
+        <c:txPr>
+          <a:bodyPr/>
+          <a:lstStyle/>
+          <a:p>
+            <a:pPr>
+              <a:defRPr sz="1200" b="0" i="0" u="none" strike="noStrike">
+                <a:solidFill>
+                  <a:srgbClr val="000000"/>
+                </a:solidFill>
+                <a:latin typeface="Arial"/>
+              </a:defRPr>
+            </a:pPr>
+            <a:endParaRPr lang="en-US"/>
+          </a:p>
+        </c:txPr>
+        <c:crossAx val="2094734554"/>
+        <c:crosses val="autoZero"/>
+        <c:crossBetween val="between"/>
+      </c:valAx>
+      <c:spPr>
+        <a:noFill/>
+        <a:ln>
+          <a:noFill/>
+        </a:ln>
+        <a:effectLst/>
+      </c:spPr>
+    </c:plotArea>
+    <c:legend>
+      <c:legendPos val="b"/>
+      <c:overlay val="0"/>
+      <c:txPr>
+        <a:bodyPr/>
+        <a:lstStyle/>
+        <a:p>
+          <a:pPr>
+            <a:defRPr sz="1000">
+              <a:solidFill>
+                <a:srgbClr val="16233D"/>
+              </a:solidFill>
+              <a:latin typeface="Calibri"/>
+              <a:cs typeface="Calibri"/>
+            </a:defRPr>
+          </a:pPr>
+          <a:endParaRPr lang="en-US"/>
+        </a:p>
+      </c:txPr>
+    </c:legend>
+    <c:plotVisOnly val="1"/>
+    <c:dispBlanksAs val="span"/>
+  </c:chart>
+  <c:spPr>
+    <a:noFill/>
+    <a:ln>
+      <a:noFill/>
+    </a:ln>
+    <a:effectLst/>
+  </c:spPr>
+  <c:externalData r:id="rId1">
+    <c:autoUpdate val="0"/>
+  </c:externalData>
+</c:chartSpace>
+</file>
+
+<file path=ppt/charts/chart5.xml><?xml version="1.0" encoding="utf-8"?>
+<c:chartSpace xmlns:c="http://schemas.openxmlformats.org/drawingml/2006/chart" xmlns:a="http://schemas.openxmlformats.org/drawingml/2006/main" xmlns:r="http://schemas.openxmlformats.org/officeDocument/2006/relationships">
+  <c:date1904 val="0"/>
+  <c:roundedCorners val="1"/>
+  <c:chart>
+    <c:title>
+      <c:tx>
+        <c:rich>
+          <a:bodyPr/>
+          <a:lstStyle/>
+          <a:p>
+            <a:pPr>
+              <a:defRPr sz="1200" b="0" i="0" u="none" strike="noStrike">
+                <a:solidFill>
+                  <a:srgbClr val="16233D"/>
+                </a:solidFill>
+                <a:latin typeface="Calibri"/>
+              </a:defRPr>
+            </a:pPr>
+            <a:r>
+              <a:rPr sz="1200" b="0" i="0" u="none" strike="noStrike">
+                <a:solidFill>
+                  <a:srgbClr val="16233D"/>
+                </a:solidFill>
+                <a:latin typeface="Calibri"/>
+              </a:rPr>
+              <a:t>TRUE ecosystem (% of customers)</a:t>
+            </a:r>
+          </a:p>
+        </c:rich>
+      </c:tx>
+      <c:layout/>
+      <c:overlay val="0"/>
+    </c:title>
+    <c:autoTitleDeleted val="0"/>
+    <c:plotArea>
+      <c:layout/>
+      <c:barChart>
+        <c:barDir val="bar"/>
+        <c:grouping val="percentStacked"/>
+        <c:varyColors val="0"/>
+        <c:ser>
+          <c:idx val="0"/>
+          <c:order val="0"/>
+          <c:tx>
+            <c:strRef>
+              <c:f>Sheet1!$B$1</c:f>
+              <c:strCache>
+                <c:ptCount val="1"/>
+                <c:pt idx="0">
+                  <c:v>N</c:v>
+                </c:pt>
+              </c:strCache>
+            </c:strRef>
+          </c:tx>
+          <c:spPr>
+            <a:solidFill>
+              <a:srgbClr val="8DA0B8"/>
+            </a:solidFill>
+            <a:effectLst/>
+          </c:spPr>
+          <c:invertIfNegative val="0"/>
+          <c:dLbls>
+            <c:numFmt formatCode="0.0&quot;%&quot;" sourceLinked="0"/>
+            <c:txPr>
+              <a:bodyPr/>
+              <a:lstStyle/>
+              <a:p>
+                <a:pPr>
+                  <a:defRPr b="0" i="0" strike="noStrike" sz="950" u="none">
+                    <a:solidFill>
+                      <a:srgbClr val="FFFFFF"/>
+                    </a:solidFill>
+                    <a:latin typeface="Calibri"/>
+                  </a:defRPr>
+                </a:pPr>
+              </a:p>
+            </c:txPr>
+            <c:dLblPos val="ctr"/>
+            <c:showLegendKey val="0"/>
+            <c:showVal val="1"/>
+            <c:showCatName val="0"/>
+            <c:showSerName val="0"/>
+            <c:showPercent val="0"/>
+            <c:showBubbleSize val="0"/>
+            <c:showLeaderLines val="0"/>
+          </c:dLbls>
+          <c:cat>
+            <c:multiLvlStrRef>
+              <c:f>Sheet1!$A$2:$A$3</c:f>
+              <c:multiLvlStrCache>
+                <c:ptCount val="2"/>
+                <c:lvl>
+                  <c:pt idx="0">
+                    <c:v>DL</c:v>
+                  </c:pt>
+                  <c:pt idx="1">
+                    <c:v>PL</c:v>
+                  </c:pt>
+                </c:lvl>
+              </c:multiLvlStrCache>
+            </c:multiLvlStrRef>
+          </c:cat>
+          <c:val>
+            <c:numRef>
+              <c:f>Sheet1!$B$2:$B$3</c:f>
+              <c:numCache>
+                <c:formatCode>General</c:formatCode>
+                <c:ptCount val="2"/>
+                <c:pt idx="0">
+                  <c:v>31.5</c:v>
+                </c:pt>
+                <c:pt idx="1">
+                  <c:v>34.7</c:v>
+                </c:pt>
+              </c:numCache>
+            </c:numRef>
+          </c:val>
+        </c:ser>
+        <c:ser>
+          <c:idx val="1"/>
+          <c:order val="1"/>
+          <c:tx>
+            <c:strRef>
+              <c:f>Sheet1!$C$1</c:f>
+              <c:strCache>
+                <c:ptCount val="1"/>
+                <c:pt idx="0">
+                  <c:v>Y</c:v>
+                </c:pt>
+              </c:strCache>
+            </c:strRef>
+          </c:tx>
+          <c:spPr>
+            <a:solidFill>
+              <a:srgbClr val="165A73"/>
+            </a:solidFill>
+            <a:effectLst/>
+          </c:spPr>
+          <c:invertIfNegative val="0"/>
+          <c:dLbls>
+            <c:numFmt formatCode="0.0&quot;%&quot;" sourceLinked="0"/>
+            <c:txPr>
+              <a:bodyPr/>
+              <a:lstStyle/>
+              <a:p>
+                <a:pPr>
+                  <a:defRPr b="0" i="0" strike="noStrike" sz="950" u="none">
+                    <a:solidFill>
+                      <a:srgbClr val="FFFFFF"/>
+                    </a:solidFill>
+                    <a:latin typeface="Calibri"/>
+                  </a:defRPr>
+                </a:pPr>
+              </a:p>
+            </c:txPr>
+            <c:dLblPos val="ctr"/>
+            <c:showLegendKey val="0"/>
+            <c:showVal val="1"/>
+            <c:showCatName val="0"/>
+            <c:showSerName val="0"/>
+            <c:showPercent val="0"/>
+            <c:showBubbleSize val="0"/>
+            <c:showLeaderLines val="0"/>
+          </c:dLbls>
+          <c:cat>
+            <c:multiLvlStrRef>
+              <c:f>Sheet1!$A$2:$A$3</c:f>
+              <c:multiLvlStrCache>
+                <c:ptCount val="2"/>
+                <c:lvl>
+                  <c:pt idx="0">
+                    <c:v>DL</c:v>
+                  </c:pt>
+                  <c:pt idx="1">
+                    <c:v>PL</c:v>
+                  </c:pt>
+                </c:lvl>
+              </c:multiLvlStrCache>
+            </c:multiLvlStrRef>
+          </c:cat>
+          <c:val>
+            <c:numRef>
+              <c:f>Sheet1!$C$2:$C$3</c:f>
+              <c:numCache>
+                <c:formatCode>General</c:formatCode>
+                <c:ptCount val="2"/>
+                <c:pt idx="0">
+                  <c:v>68.5</c:v>
+                </c:pt>
+                <c:pt idx="1">
+                  <c:v>65.3</c:v>
+                </c:pt>
+              </c:numCache>
+            </c:numRef>
+          </c:val>
+        </c:ser>
+        <c:dLbls>
+          <c:numFmt formatCode="0.0&quot;%&quot;" sourceLinked="0"/>
+          <c:txPr>
+            <a:bodyPr/>
+            <a:lstStyle/>
+            <a:p>
+              <a:pPr>
+                <a:defRPr b="0" i="0" strike="noStrike" sz="950" u="none">
+                  <a:solidFill>
+                    <a:srgbClr val="FFFFFF"/>
+                  </a:solidFill>
+                  <a:latin typeface="Calibri"/>
+                </a:defRPr>
+              </a:pPr>
+            </a:p>
+          </c:txPr>
+          <c:dLblPos val="ctr"/>
+          <c:showLegendKey val="0"/>
+          <c:showVal val="1"/>
+          <c:showCatName val="0"/>
+          <c:showSerName val="0"/>
+          <c:showPercent val="0"/>
+          <c:showBubbleSize val="0"/>
+          <c:showLeaderLines val="0"/>
+        </c:dLbls>
+        <c:gapWidth val="45"/>
+        <c:overlap val="100"/>
+        <c:axId val="2094734554"/>
+        <c:axId val="2094734552"/>
+        <c:axId val="2094734556"/>
+      </c:barChart>
+      <c:catAx>
+        <c:axId val="2094734554"/>
+        <c:scaling>
+          <c:orientation val="minMax"/>
+        </c:scaling>
+        <c:delete val="0"/>
+        <c:axPos val="l"/>
+        <c:numFmt formatCode="General" sourceLinked="1"/>
+        <c:majorTickMark val="out"/>
+        <c:minorTickMark val="none"/>
+        <c:tickLblPos val="nextTo"/>
+        <c:spPr>
+          <a:ln w="12700" cap="flat">
+            <a:solidFill>
+              <a:srgbClr val="888888"/>
+            </a:solidFill>
+            <a:prstDash val="solid"/>
+            <a:round/>
+          </a:ln>
+        </c:spPr>
+        <c:txPr>
+          <a:bodyPr/>
+          <a:lstStyle/>
+          <a:p>
+            <a:pPr>
+              <a:defRPr sz="1100" b="0" i="0" u="none" strike="noStrike">
+                <a:solidFill>
+                  <a:srgbClr val="16233D"/>
+                </a:solidFill>
+                <a:latin typeface="Calibri"/>
+              </a:defRPr>
+            </a:pPr>
+            <a:endParaRPr lang="en-US"/>
+          </a:p>
+        </c:txPr>
+        <c:crossAx val="2094734552"/>
+        <c:crosses val="autoZero"/>
+        <c:auto val="1"/>
+        <c:lblAlgn val="ctr"/>
+        <c:noMultiLvlLbl val="1"/>
+      </c:catAx>
+      <c:valAx>
+        <c:axId val="2094734552"/>
+        <c:scaling>
+          <c:orientation val="minMax"/>
+        </c:scaling>
+        <c:delete val="1"/>
+        <c:axPos val="b"/>
+        <c:numFmt formatCode="General" sourceLinked="0"/>
+        <c:majorTickMark val="out"/>
+        <c:minorTickMark val="none"/>
+        <c:tickLblPos val="low"/>
+        <c:spPr>
+          <a:ln w="12700" cap="flat">
+            <a:solidFill>
+              <a:srgbClr val="888888"/>
+            </a:solidFill>
+            <a:prstDash val="solid"/>
+            <a:round/>
+          </a:ln>
+        </c:spPr>
+        <c:txPr>
+          <a:bodyPr/>
+          <a:lstStyle/>
+          <a:p>
+            <a:pPr>
+              <a:defRPr sz="1200" b="0" i="0" u="none" strike="noStrike">
+                <a:solidFill>
+                  <a:srgbClr val="000000"/>
+                </a:solidFill>
+                <a:latin typeface="Arial"/>
+              </a:defRPr>
+            </a:pPr>
+            <a:endParaRPr lang="en-US"/>
+          </a:p>
+        </c:txPr>
+        <c:crossAx val="2094734554"/>
+        <c:crosses val="autoZero"/>
+        <c:crossBetween val="between"/>
+      </c:valAx>
+      <c:spPr>
+        <a:noFill/>
+        <a:ln>
+          <a:noFill/>
+        </a:ln>
+        <a:effectLst/>
+      </c:spPr>
+    </c:plotArea>
+    <c:legend>
+      <c:legendPos val="b"/>
+      <c:overlay val="0"/>
+      <c:txPr>
+        <a:bodyPr/>
+        <a:lstStyle/>
+        <a:p>
+          <a:pPr>
+            <a:defRPr sz="1000">
+              <a:solidFill>
+                <a:srgbClr val="16233D"/>
+              </a:solidFill>
+              <a:latin typeface="Calibri"/>
+              <a:cs typeface="Calibri"/>
+            </a:defRPr>
+          </a:pPr>
+          <a:endParaRPr lang="en-US"/>
+        </a:p>
+      </c:txPr>
+    </c:legend>
+    <c:plotVisOnly val="1"/>
+    <c:dispBlanksAs val="span"/>
+  </c:chart>
+  <c:spPr>
+    <a:noFill/>
+    <a:ln>
+      <a:noFill/>
+    </a:ln>
+    <a:effectLst/>
+  </c:spPr>
+  <c:externalData r:id="rId1">
+    <c:autoUpdate val="0"/>
+  </c:externalData>
+</c:chartSpace>
+</file>
+
 <file path=ppt/notesMasters/notesMaster1.xml><?xml version="1.0" encoding="utf-8"?>
 <p:notesMaster xmlns:a="http://schemas.openxmlformats.org/drawingml/2006/main" xmlns:r="http://schemas.openxmlformats.org/officeDocument/2006/relationships" xmlns:p="http://schemas.openxmlformats.org/presentationml/2006/main">
   <p:cSld>
@@ -1082,6 +2647,94 @@
             <a:fld id="{F7021451-1387-4CA6-816F-3879F97B5CBC}" type="slidenum">
               <a:rPr lang="en-US"/>
               <a:t>1</a:t>
+            </a:fld>
+            <a:endParaRPr lang="en-US"/>
+          </a:p>
+        </p:txBody>
+      </p:sp>
+    </p:spTree>
+    <p:extLst>
+      <p:ext uri="{BB962C8B-B14F-4D97-AF65-F5344CB8AC3E}">
+        <p14:creationId xmlns:p14="http://schemas.microsoft.com/office/powerpoint/2010/main" val="1024086991"/>
+      </p:ext>
+    </p:extLst>
+  </p:cSld>
+  <p:clrMapOvr>
+    <a:masterClrMapping/>
+  </p:clrMapOvr>
+</p:notes>
+</file>
+
+<file path=ppt/notesSlides/notesSlide2.xml><?xml version="1.0" encoding="utf-8"?>
+<p:notes xmlns:a="http://schemas.openxmlformats.org/drawingml/2006/main" xmlns:r="http://schemas.openxmlformats.org/officeDocument/2006/relationships" xmlns:p="http://schemas.openxmlformats.org/presentationml/2006/main">
+  <p:cSld>
+    <p:spTree>
+      <p:nvGrpSpPr>
+        <p:cNvPr id="1" name=""/>
+        <p:cNvGrpSpPr/>
+        <p:nvPr/>
+      </p:nvGrpSpPr>
+      <p:grpSpPr>
+        <a:xfrm>
+          <a:off x="0" y="0"/>
+          <a:ext cx="0" cy="0"/>
+          <a:chOff x="0" y="0"/>
+          <a:chExt cx="0" cy="0"/>
+        </a:xfrm>
+      </p:grpSpPr>
+      <p:sp>
+        <p:nvSpPr>
+          <p:cNvPr id="2" name="Slide Image Placeholder 1"/>
+          <p:cNvSpPr>
+            <a:spLocks noGrp="1" noRot="1" noChangeAspect="1"/>
+          </p:cNvSpPr>
+          <p:nvPr>
+            <p:ph type="sldImg"/>
+          </p:nvPr>
+        </p:nvSpPr>
+        <p:spPr/>
+      </p:sp>
+      <p:sp>
+        <p:nvSpPr>
+          <p:cNvPr id="3" name="Notes Placeholder 2"/>
+          <p:cNvSpPr>
+            <a:spLocks noGrp="1"/>
+          </p:cNvSpPr>
+          <p:nvPr>
+            <p:ph type="body" idx="1"/>
+          </p:nvPr>
+        </p:nvSpPr>
+        <p:spPr/>
+        <p:txBody>
+          <a:bodyPr/>
+          <a:lstStyle/>
+          <a:p>
+            <a:r>
+              <a:rPr lang="en-US" dirty="0"/>
+              <a:t>Charts use the same percent-stacked form as the cash-need and risk chart on slide 1. Biggest DL/PL gaps: nano-loan flag Y is 61.8% for DL against 53.8% for PL, and PL skews further to prepaid (56.0% vs 48.8%) with correspondingly less postpaid (37.8% vs 44.7%). Tenure and TRUE are within ~3 points across the two loan types. Counts behind the percentages - DL 63,760 and PL 6,340, totalling 70,100.</a:t>
+            </a:r>
+            <a:endParaRPr lang="en-US" dirty="0"/>
+          </a:p>
+        </p:txBody>
+      </p:sp>
+      <p:sp>
+        <p:nvSpPr>
+          <p:cNvPr id="4" name="Slide Number Placeholder 3"/>
+          <p:cNvSpPr>
+            <a:spLocks noGrp="1"/>
+          </p:cNvSpPr>
+          <p:nvPr>
+            <p:ph type="sldNum" sz="quarter" idx="10"/>
+          </p:nvPr>
+        </p:nvSpPr>
+        <p:spPr/>
+        <p:txBody>
+          <a:bodyPr/>
+          <a:lstStyle/>
+          <a:p>
+            <a:fld id="{F7021451-1387-4CA6-816F-3879F97B5CBC}" type="slidenum">
+              <a:rPr lang="en-US"/>
+              <a:t>2</a:t>
             </a:fld>
             <a:endParaRPr lang="en-US"/>
           </a:p>
@@ -2864,6 +4517,346 @@
 </p:sld>
 </file>
 
+<file path=ppt/slides/slide2.xml><?xml version="1.0" encoding="utf-8"?>
+<p:sld xmlns:a="http://schemas.openxmlformats.org/drawingml/2006/main" xmlns:r="http://schemas.openxmlformats.org/officeDocument/2006/relationships" xmlns:p="http://schemas.openxmlformats.org/presentationml/2006/main">
+  <p:cSld name="Slide 2">
+    <p:bg>
+      <p:bgPr>
+        <a:solidFill>
+          <a:srgbClr val="FFFFFF"/>
+        </a:solidFill>
+      </p:bgPr>
+    </p:bg>
+    <p:spTree>
+      <p:nvGrpSpPr>
+        <p:cNvPr id="1" name=""/>
+        <p:cNvGrpSpPr/>
+        <p:nvPr/>
+      </p:nvGrpSpPr>
+      <p:grpSpPr>
+        <a:xfrm>
+          <a:off x="0" y="0"/>
+          <a:ext cx="0" cy="0"/>
+          <a:chOff x="0" y="0"/>
+          <a:chExt cx="0" cy="0"/>
+        </a:xfrm>
+      </p:grpSpPr>
+      <p:sp>
+        <p:nvSpPr>
+          <p:cNvPr id="2" name="Text 0"/>
+          <p:cNvSpPr/>
+          <p:nvPr/>
+        </p:nvSpPr>
+        <p:spPr>
+          <a:xfrm>
+            <a:off x="548640" y="329184"/>
+            <a:ext cx="11064240" cy="237744"/>
+          </a:xfrm>
+          <a:prstGeom prst="rect">
+            <a:avLst/>
+          </a:prstGeom>
+          <a:noFill/>
+          <a:ln/>
+        </p:spPr>
+        <p:txBody>
+          <a:bodyPr wrap="square" lIns="0" tIns="0" rIns="0" bIns="0" rtlCol="0" anchor="ctr"/>
+          <a:lstStyle/>
+          <a:p>
+            <a:pPr indent="0" marL="0">
+              <a:buNone/>
+            </a:pPr>
+            <a:r>
+              <a:rPr lang="en-US" sz="1150" b="1" spc="220" kern="0" dirty="0">
+                <a:solidFill>
+                  <a:srgbClr val="00A896"/>
+                </a:solidFill>
+                <a:latin typeface="Calibri" pitchFamily="34" charset="0"/>
+                <a:ea typeface="Calibri" pitchFamily="34" charset="-122"/>
+                <a:cs typeface="Calibri" pitchFamily="34" charset="-120"/>
+              </a:rPr>
+              <a:t>AIS BASE INFORMATION  ·  70.1K  ·  DL 63,760 / PL 6,340</a:t>
+            </a:r>
+            <a:endParaRPr lang="en-US" sz="1150" dirty="0"/>
+          </a:p>
+        </p:txBody>
+      </p:sp>
+      <p:sp>
+        <p:nvSpPr>
+          <p:cNvPr id="3" name="Text 1"/>
+          <p:cNvSpPr/>
+          <p:nvPr/>
+        </p:nvSpPr>
+        <p:spPr>
+          <a:xfrm>
+            <a:off x="548640" y="603504"/>
+            <a:ext cx="11064240" cy="566928"/>
+          </a:xfrm>
+          <a:prstGeom prst="rect">
+            <a:avLst/>
+          </a:prstGeom>
+          <a:noFill/>
+          <a:ln/>
+        </p:spPr>
+        <p:txBody>
+          <a:bodyPr wrap="square" lIns="0" tIns="0" rIns="0" bIns="0" rtlCol="0" anchor="t"/>
+          <a:lstStyle/>
+          <a:p>
+            <a:pPr indent="0" marL="0">
+              <a:buNone/>
+            </a:pPr>
+            <a:r>
+              <a:rPr lang="en-US" sz="3200" b="1" dirty="0">
+                <a:solidFill>
+                  <a:srgbClr val="16233D"/>
+                </a:solidFill>
+                <a:latin typeface="Cambria" pitchFamily="34" charset="0"/>
+                <a:ea typeface="Cambria" pitchFamily="34" charset="-122"/>
+                <a:cs typeface="Cambria" pitchFamily="34" charset="-120"/>
+              </a:rPr>
+              <a:t>Long-tenured, prepaid-leaning, mostly TRUE</a:t>
+            </a:r>
+            <a:endParaRPr lang="en-US" sz="3200" dirty="0"/>
+          </a:p>
+        </p:txBody>
+      </p:sp>
+      <p:sp>
+        <p:nvSpPr>
+          <p:cNvPr id="4" name="Text 2"/>
+          <p:cNvSpPr/>
+          <p:nvPr/>
+        </p:nvSpPr>
+        <p:spPr>
+          <a:xfrm>
+            <a:off x="548640" y="1097280"/>
+            <a:ext cx="11064240" cy="256032"/>
+          </a:xfrm>
+          <a:prstGeom prst="rect">
+            <a:avLst/>
+          </a:prstGeom>
+          <a:noFill/>
+          <a:ln/>
+        </p:spPr>
+        <p:txBody>
+          <a:bodyPr wrap="square" lIns="0" tIns="0" rIns="0" bIns="0" rtlCol="0" anchor="t"/>
+          <a:lstStyle/>
+          <a:p>
+            <a:pPr indent="0" marL="0">
+              <a:buNone/>
+            </a:pPr>
+            <a:r>
+              <a:rPr lang="en-US" sz="1250" dirty="0">
+                <a:solidFill>
+                  <a:srgbClr val="6B7A90"/>
+                </a:solidFill>
+                <a:latin typeface="Calibri" pitchFamily="34" charset="0"/>
+                <a:ea typeface="Calibri" pitchFamily="34" charset="-122"/>
+                <a:cs typeface="Calibri" pitchFamily="34" charset="-120"/>
+              </a:rPr>
+              <a:t>DL and PL profile almost identically on tenure and TRUE; they part company on charge type and the nano-loan flag.</a:t>
+            </a:r>
+            <a:endParaRPr lang="en-US" sz="1250" dirty="0"/>
+          </a:p>
+        </p:txBody>
+      </p:sp>
+      <p:sp>
+        <p:nvSpPr>
+          <p:cNvPr id="5" name="Shape 3"/>
+          <p:cNvSpPr/>
+          <p:nvPr/>
+        </p:nvSpPr>
+        <p:spPr>
+          <a:xfrm>
+            <a:off x="548640" y="1463040"/>
+            <a:ext cx="5440680" cy="2231136"/>
+          </a:xfrm>
+          <a:prstGeom prst="roundRect">
+            <a:avLst>
+              <a:gd name="adj" fmla="val 3689"/>
+            </a:avLst>
+          </a:prstGeom>
+          <a:solidFill>
+            <a:srgbClr val="F1F4F9"/>
+          </a:solidFill>
+          <a:ln/>
+        </p:spPr>
+      </p:sp>
+      <p:graphicFrame>
+        <p:nvGraphicFramePr>
+          <p:cNvPr id="6" name="Chart 0" descr=""/>
+          <p:cNvGraphicFramePr/>
+          <p:nvPr/>
+        </p:nvGraphicFramePr>
+        <p:xfrm>
+          <a:off x="658368" y="1554480"/>
+          <a:ext cx="5221224" cy="2048256"/>
+        </p:xfrm>
+        <a:graphic xmlns:a="http://schemas.openxmlformats.org/drawingml/2006/main">
+          <a:graphicData uri="http://schemas.openxmlformats.org/drawingml/2006/chart">
+            <c:chart xmlns:c="http://schemas.openxmlformats.org/drawingml/2006/chart" r:id="rId1"/>
+          </a:graphicData>
+        </a:graphic>
+      </p:graphicFrame>
+      <p:sp>
+        <p:nvSpPr>
+          <p:cNvPr id="7" name="Shape 4"/>
+          <p:cNvSpPr/>
+          <p:nvPr/>
+        </p:nvSpPr>
+        <p:spPr>
+          <a:xfrm>
+            <a:off x="6172200" y="1463040"/>
+            <a:ext cx="5440680" cy="2231136"/>
+          </a:xfrm>
+          <a:prstGeom prst="roundRect">
+            <a:avLst>
+              <a:gd name="adj" fmla="val 3689"/>
+            </a:avLst>
+          </a:prstGeom>
+          <a:solidFill>
+            <a:srgbClr val="F1F4F9"/>
+          </a:solidFill>
+          <a:ln/>
+        </p:spPr>
+      </p:sp>
+      <p:graphicFrame>
+        <p:nvGraphicFramePr>
+          <p:cNvPr id="8" name="Chart 1" descr=""/>
+          <p:cNvGraphicFramePr/>
+          <p:nvPr/>
+        </p:nvGraphicFramePr>
+        <p:xfrm>
+          <a:off x="6281928" y="1554480"/>
+          <a:ext cx="5221224" cy="2048256"/>
+        </p:xfrm>
+        <a:graphic xmlns:a="http://schemas.openxmlformats.org/drawingml/2006/main">
+          <a:graphicData uri="http://schemas.openxmlformats.org/drawingml/2006/chart">
+            <c:chart xmlns:c="http://schemas.openxmlformats.org/drawingml/2006/chart" r:id="rId2"/>
+          </a:graphicData>
+        </a:graphic>
+      </p:graphicFrame>
+      <p:sp>
+        <p:nvSpPr>
+          <p:cNvPr id="9" name="Shape 5"/>
+          <p:cNvSpPr/>
+          <p:nvPr/>
+        </p:nvSpPr>
+        <p:spPr>
+          <a:xfrm>
+            <a:off x="548640" y="3840480"/>
+            <a:ext cx="5440680" cy="2231136"/>
+          </a:xfrm>
+          <a:prstGeom prst="roundRect">
+            <a:avLst>
+              <a:gd name="adj" fmla="val 3689"/>
+            </a:avLst>
+          </a:prstGeom>
+          <a:solidFill>
+            <a:srgbClr val="F1F4F9"/>
+          </a:solidFill>
+          <a:ln/>
+        </p:spPr>
+      </p:sp>
+      <p:graphicFrame>
+        <p:nvGraphicFramePr>
+          <p:cNvPr id="10" name="Chart 2" descr=""/>
+          <p:cNvGraphicFramePr/>
+          <p:nvPr/>
+        </p:nvGraphicFramePr>
+        <p:xfrm>
+          <a:off x="658368" y="3931920"/>
+          <a:ext cx="5221224" cy="2048256"/>
+        </p:xfrm>
+        <a:graphic xmlns:a="http://schemas.openxmlformats.org/drawingml/2006/main">
+          <a:graphicData uri="http://schemas.openxmlformats.org/drawingml/2006/chart">
+            <c:chart xmlns:c="http://schemas.openxmlformats.org/drawingml/2006/chart" r:id="rId3"/>
+          </a:graphicData>
+        </a:graphic>
+      </p:graphicFrame>
+      <p:sp>
+        <p:nvSpPr>
+          <p:cNvPr id="11" name="Shape 6"/>
+          <p:cNvSpPr/>
+          <p:nvPr/>
+        </p:nvSpPr>
+        <p:spPr>
+          <a:xfrm>
+            <a:off x="6172200" y="3840480"/>
+            <a:ext cx="5440680" cy="2231136"/>
+          </a:xfrm>
+          <a:prstGeom prst="roundRect">
+            <a:avLst>
+              <a:gd name="adj" fmla="val 3689"/>
+            </a:avLst>
+          </a:prstGeom>
+          <a:solidFill>
+            <a:srgbClr val="F1F4F9"/>
+          </a:solidFill>
+          <a:ln/>
+        </p:spPr>
+      </p:sp>
+      <p:graphicFrame>
+        <p:nvGraphicFramePr>
+          <p:cNvPr id="12" name="Chart 3" descr=""/>
+          <p:cNvGraphicFramePr/>
+          <p:nvPr/>
+        </p:nvGraphicFramePr>
+        <p:xfrm>
+          <a:off x="6281928" y="3931920"/>
+          <a:ext cx="5221224" cy="2048256"/>
+        </p:xfrm>
+        <a:graphic xmlns:a="http://schemas.openxmlformats.org/drawingml/2006/main">
+          <a:graphicData uri="http://schemas.openxmlformats.org/drawingml/2006/chart">
+            <c:chart xmlns:c="http://schemas.openxmlformats.org/drawingml/2006/chart" r:id="rId4"/>
+          </a:graphicData>
+        </a:graphic>
+      </p:graphicFrame>
+      <p:sp>
+        <p:nvSpPr>
+          <p:cNvPr id="13" name="Text 7"/>
+          <p:cNvSpPr/>
+          <p:nvPr/>
+        </p:nvSpPr>
+        <p:spPr>
+          <a:xfrm>
+            <a:off x="548640" y="6309360"/>
+            <a:ext cx="11064240" cy="384048"/>
+          </a:xfrm>
+          <a:prstGeom prst="rect">
+            <a:avLst/>
+          </a:prstGeom>
+          <a:noFill/>
+          <a:ln/>
+        </p:spPr>
+        <p:txBody>
+          <a:bodyPr wrap="square" lIns="0" tIns="0" rIns="0" bIns="0" rtlCol="0" anchor="ctr"/>
+          <a:lstStyle/>
+          <a:p>
+            <a:pPr indent="0" marL="0">
+              <a:buNone/>
+            </a:pPr>
+            <a:r>
+              <a:rPr lang="en-US" sz="900" i="1" dirty="0">
+                <a:solidFill>
+                  <a:srgbClr val="6B7A90"/>
+                </a:solidFill>
+                <a:latin typeface="Calibri" pitchFamily="34" charset="0"/>
+                <a:ea typeface="Calibri" pitchFamily="34" charset="-122"/>
+                <a:cs typeface="Calibri" pitchFamily="34" charset="-120"/>
+              </a:rPr>
+              <a:t>Source: Lending_2026.08.07.pptx, the four AIS Base Information slides (charge type, nano loan, true, tenure), aggregated across all book dates. Each breakdown sums to 70,100, matching the stated AIS consortium count. Percentages are computed from the deck's own counts and may differ by 1pt from its per-date rounding.</a:t>
+            </a:r>
+            <a:endParaRPr lang="en-US" sz="900" dirty="0"/>
+          </a:p>
+        </p:txBody>
+      </p:sp>
+    </p:spTree>
+  </p:cSld>
+  <p:clrMapOvr>
+    <a:masterClrMapping/>
+  </p:clrMapOvr>
+</p:sld>
+</file>
+
 <file path=ppt/theme/theme1.xml><?xml version="1.0" encoding="utf-8"?>
 <a:theme xmlns:a="http://schemas.openxmlformats.org/drawingml/2006/main" name="Office Theme">
   <a:themeElements>

</xml_diff>

<commit_message>
Chart AIS book date as a third slide
Adds booking volume by book date (DL vs PL, clustered columns) plus the
two mixes that actually shift across cohorts - nano-loan flag and TRUE
ecosystem - as percent-stacked columns on the same date axis.

Charge type and tenure are effectively flat across the August dates
(prepaid 46-55%, tenure 5+ years 65-68%), so they stay on the by-loan-type
slide; the footnote says so and gives their ranges.

Co-Authored-By: Claude Opus 5 <noreply@anthropic.com>
Claude-Session: https://claude.ai/code/session_01VKpfo226Go9vQJYa4eoC1d
</commit_message>
<xml_diff>
--- a/Lending_Book_Loan_Summary.pptx
+++ b/Lending_Book_Loan_Summary.pptx
@@ -7,9 +7,10 @@
   <p:sldIdLst>
     <p:sldId id="256" r:id="rId2"/>
     <p:sldId id="257" r:id="rId3"/>
+    <p:sldId id="258" r:id="rId4"/>
   </p:sldIdLst>
   <p:notesMasterIdLst>
-    <p:notesMasterId r:id="rId4"/>
+    <p:notesMasterId r:id="rId5"/>
   </p:notesMasterIdLst>
   <p:sldSz cx="12192000" cy="6858000"/>
   <p:notesSz cx="6858000" cy="12192000"/>
@@ -2156,6 +2157,1205 @@
         <c:majorTickMark val="out"/>
         <c:minorTickMark val="none"/>
         <c:tickLblPos val="low"/>
+        <c:spPr>
+          <a:ln w="12700" cap="flat">
+            <a:solidFill>
+              <a:srgbClr val="888888"/>
+            </a:solidFill>
+            <a:prstDash val="solid"/>
+            <a:round/>
+          </a:ln>
+        </c:spPr>
+        <c:txPr>
+          <a:bodyPr/>
+          <a:lstStyle/>
+          <a:p>
+            <a:pPr>
+              <a:defRPr sz="1200" b="0" i="0" u="none" strike="noStrike">
+                <a:solidFill>
+                  <a:srgbClr val="000000"/>
+                </a:solidFill>
+                <a:latin typeface="Arial"/>
+              </a:defRPr>
+            </a:pPr>
+            <a:endParaRPr lang="en-US"/>
+          </a:p>
+        </c:txPr>
+        <c:crossAx val="2094734554"/>
+        <c:crosses val="autoZero"/>
+        <c:crossBetween val="between"/>
+      </c:valAx>
+      <c:spPr>
+        <a:noFill/>
+        <a:ln>
+          <a:noFill/>
+        </a:ln>
+        <a:effectLst/>
+      </c:spPr>
+    </c:plotArea>
+    <c:legend>
+      <c:legendPos val="b"/>
+      <c:overlay val="0"/>
+      <c:txPr>
+        <a:bodyPr/>
+        <a:lstStyle/>
+        <a:p>
+          <a:pPr>
+            <a:defRPr sz="1000">
+              <a:solidFill>
+                <a:srgbClr val="16233D"/>
+              </a:solidFill>
+              <a:latin typeface="Calibri"/>
+              <a:cs typeface="Calibri"/>
+            </a:defRPr>
+          </a:pPr>
+          <a:endParaRPr lang="en-US"/>
+        </a:p>
+      </c:txPr>
+    </c:legend>
+    <c:plotVisOnly val="1"/>
+    <c:dispBlanksAs val="span"/>
+  </c:chart>
+  <c:spPr>
+    <a:noFill/>
+    <a:ln>
+      <a:noFill/>
+    </a:ln>
+    <a:effectLst/>
+  </c:spPr>
+  <c:externalData r:id="rId1">
+    <c:autoUpdate val="0"/>
+  </c:externalData>
+</c:chartSpace>
+</file>
+
+<file path=ppt/charts/chart6.xml><?xml version="1.0" encoding="utf-8"?>
+<c:chartSpace xmlns:c="http://schemas.openxmlformats.org/drawingml/2006/chart" xmlns:a="http://schemas.openxmlformats.org/drawingml/2006/main" xmlns:r="http://schemas.openxmlformats.org/officeDocument/2006/relationships">
+  <c:date1904 val="0"/>
+  <c:roundedCorners val="1"/>
+  <c:chart>
+    <c:title>
+      <c:tx>
+        <c:rich>
+          <a:bodyPr/>
+          <a:lstStyle/>
+          <a:p>
+            <a:pPr>
+              <a:defRPr sz="1200" b="0" i="0" u="none" strike="noStrike">
+                <a:solidFill>
+                  <a:srgbClr val="16233D"/>
+                </a:solidFill>
+                <a:latin typeface="Calibri"/>
+              </a:defRPr>
+            </a:pPr>
+            <a:r>
+              <a:rPr sz="1200" b="0" i="0" u="none" strike="noStrike">
+                <a:solidFill>
+                  <a:srgbClr val="16233D"/>
+                </a:solidFill>
+                <a:latin typeface="Calibri"/>
+              </a:rPr>
+              <a:t>Bookings by book date (customers)</a:t>
+            </a:r>
+          </a:p>
+        </c:rich>
+      </c:tx>
+      <c:layout/>
+      <c:overlay val="0"/>
+    </c:title>
+    <c:autoTitleDeleted val="0"/>
+    <c:plotArea>
+      <c:layout/>
+      <c:barChart>
+        <c:barDir val="col"/>
+        <c:grouping val="clustered"/>
+        <c:varyColors val="0"/>
+        <c:ser>
+          <c:idx val="0"/>
+          <c:order val="0"/>
+          <c:tx>
+            <c:strRef>
+              <c:f>Sheet1!$B$1</c:f>
+              <c:strCache>
+                <c:ptCount val="1"/>
+                <c:pt idx="0">
+                  <c:v>DL</c:v>
+                </c:pt>
+              </c:strCache>
+            </c:strRef>
+          </c:tx>
+          <c:spPr>
+            <a:solidFill>
+              <a:srgbClr val="165A73"/>
+            </a:solidFill>
+            <a:effectLst/>
+          </c:spPr>
+          <c:invertIfNegative val="0"/>
+          <c:dLbls>
+            <c:numFmt formatCode="#,##0" sourceLinked="0"/>
+            <c:txPr>
+              <a:bodyPr/>
+              <a:lstStyle/>
+              <a:p>
+                <a:pPr>
+                  <a:defRPr b="0" i="0" strike="noStrike" sz="950" u="none">
+                    <a:solidFill>
+                      <a:srgbClr val="16233D"/>
+                    </a:solidFill>
+                    <a:latin typeface="Calibri"/>
+                  </a:defRPr>
+                </a:pPr>
+              </a:p>
+            </c:txPr>
+            <c:showLegendKey val="0"/>
+            <c:showVal val="1"/>
+            <c:showCatName val="0"/>
+            <c:showSerName val="0"/>
+            <c:showPercent val="0"/>
+            <c:showBubbleSize val="0"/>
+            <c:showLeaderLines val="0"/>
+          </c:dLbls>
+          <c:cat>
+            <c:multiLvlStrRef>
+              <c:f>Sheet1!$A$2:$A$7</c:f>
+              <c:multiLvlStrCache>
+                <c:ptCount val="6"/>
+                <c:lvl>
+                  <c:pt idx="0">
+                    <c:v>bef 1 Aug</c:v>
+                  </c:pt>
+                  <c:pt idx="1">
+                    <c:v>1-Aug</c:v>
+                  </c:pt>
+                  <c:pt idx="2">
+                    <c:v>2-Aug</c:v>
+                  </c:pt>
+                  <c:pt idx="3">
+                    <c:v>3-Aug</c:v>
+                  </c:pt>
+                  <c:pt idx="4">
+                    <c:v>4-Aug</c:v>
+                  </c:pt>
+                  <c:pt idx="5">
+                    <c:v>5-Aug</c:v>
+                  </c:pt>
+                </c:lvl>
+              </c:multiLvlStrCache>
+            </c:multiLvlStrRef>
+          </c:cat>
+          <c:val>
+            <c:numRef>
+              <c:f>Sheet1!$B$2:$B$7</c:f>
+              <c:numCache>
+                <c:formatCode>General</c:formatCode>
+                <c:ptCount val="6"/>
+                <c:pt idx="0">
+                  <c:v>641</c:v>
+                </c:pt>
+                <c:pt idx="1">
+                  <c:v>12182</c:v>
+                </c:pt>
+                <c:pt idx="2">
+                  <c:v>32182</c:v>
+                </c:pt>
+                <c:pt idx="3">
+                  <c:v>2060</c:v>
+                </c:pt>
+                <c:pt idx="4">
+                  <c:v>7173</c:v>
+                </c:pt>
+                <c:pt idx="5">
+                  <c:v>9522</c:v>
+                </c:pt>
+              </c:numCache>
+            </c:numRef>
+          </c:val>
+        </c:ser>
+        <c:ser>
+          <c:idx val="1"/>
+          <c:order val="1"/>
+          <c:tx>
+            <c:strRef>
+              <c:f>Sheet1!$C$1</c:f>
+              <c:strCache>
+                <c:ptCount val="1"/>
+                <c:pt idx="0">
+                  <c:v>PL</c:v>
+                </c:pt>
+              </c:strCache>
+            </c:strRef>
+          </c:tx>
+          <c:spPr>
+            <a:solidFill>
+              <a:srgbClr val="3FB89F"/>
+            </a:solidFill>
+            <a:effectLst/>
+          </c:spPr>
+          <c:invertIfNegative val="0"/>
+          <c:dLbls>
+            <c:numFmt formatCode="#,##0" sourceLinked="0"/>
+            <c:txPr>
+              <a:bodyPr/>
+              <a:lstStyle/>
+              <a:p>
+                <a:pPr>
+                  <a:defRPr b="0" i="0" strike="noStrike" sz="950" u="none">
+                    <a:solidFill>
+                      <a:srgbClr val="16233D"/>
+                    </a:solidFill>
+                    <a:latin typeface="Calibri"/>
+                  </a:defRPr>
+                </a:pPr>
+              </a:p>
+            </c:txPr>
+            <c:showLegendKey val="0"/>
+            <c:showVal val="1"/>
+            <c:showCatName val="0"/>
+            <c:showSerName val="0"/>
+            <c:showPercent val="0"/>
+            <c:showBubbleSize val="0"/>
+            <c:showLeaderLines val="0"/>
+          </c:dLbls>
+          <c:cat>
+            <c:multiLvlStrRef>
+              <c:f>Sheet1!$A$2:$A$7</c:f>
+              <c:multiLvlStrCache>
+                <c:ptCount val="6"/>
+                <c:lvl>
+                  <c:pt idx="0">
+                    <c:v>bef 1 Aug</c:v>
+                  </c:pt>
+                  <c:pt idx="1">
+                    <c:v>1-Aug</c:v>
+                  </c:pt>
+                  <c:pt idx="2">
+                    <c:v>2-Aug</c:v>
+                  </c:pt>
+                  <c:pt idx="3">
+                    <c:v>3-Aug</c:v>
+                  </c:pt>
+                  <c:pt idx="4">
+                    <c:v>4-Aug</c:v>
+                  </c:pt>
+                  <c:pt idx="5">
+                    <c:v>5-Aug</c:v>
+                  </c:pt>
+                </c:lvl>
+              </c:multiLvlStrCache>
+            </c:multiLvlStrRef>
+          </c:cat>
+          <c:val>
+            <c:numRef>
+              <c:f>Sheet1!$C$2:$C$7</c:f>
+              <c:numCache>
+                <c:formatCode>General</c:formatCode>
+                <c:ptCount val="6"/>
+                <c:pt idx="0">
+                  <c:v>67</c:v>
+                </c:pt>
+                <c:pt idx="1">
+                  <c:v>398</c:v>
+                </c:pt>
+                <c:pt idx="2">
+                  <c:v>1159</c:v>
+                </c:pt>
+                <c:pt idx="3">
+                  <c:v>90</c:v>
+                </c:pt>
+                <c:pt idx="4">
+                  <c:v>371</c:v>
+                </c:pt>
+                <c:pt idx="5">
+                  <c:v>4255</c:v>
+                </c:pt>
+              </c:numCache>
+            </c:numRef>
+          </c:val>
+        </c:ser>
+        <c:dLbls>
+          <c:numFmt formatCode="#,##0" sourceLinked="0"/>
+          <c:txPr>
+            <a:bodyPr/>
+            <a:lstStyle/>
+            <a:p>
+              <a:pPr>
+                <a:defRPr b="0" i="0" strike="noStrike" sz="950" u="none">
+                  <a:solidFill>
+                    <a:srgbClr val="16233D"/>
+                  </a:solidFill>
+                  <a:latin typeface="Calibri"/>
+                </a:defRPr>
+              </a:pPr>
+            </a:p>
+          </c:txPr>
+          <c:showLegendKey val="0"/>
+          <c:showVal val="1"/>
+          <c:showCatName val="0"/>
+          <c:showSerName val="0"/>
+          <c:showPercent val="0"/>
+          <c:showBubbleSize val="0"/>
+          <c:showLeaderLines val="0"/>
+        </c:dLbls>
+        <c:gapWidth val="55"/>
+        <c:overlap val="0"/>
+        <c:axId val="2094734554"/>
+        <c:axId val="2094734552"/>
+        <c:axId val="2094734556"/>
+      </c:barChart>
+      <c:catAx>
+        <c:axId val="2094734554"/>
+        <c:scaling>
+          <c:orientation val="minMax"/>
+        </c:scaling>
+        <c:delete val="0"/>
+        <c:axPos val="b"/>
+        <c:numFmt formatCode="General" sourceLinked="1"/>
+        <c:majorTickMark val="out"/>
+        <c:minorTickMark val="none"/>
+        <c:tickLblPos val="low"/>
+        <c:spPr>
+          <a:ln w="12700" cap="flat">
+            <a:solidFill>
+              <a:srgbClr val="888888"/>
+            </a:solidFill>
+            <a:prstDash val="solid"/>
+            <a:round/>
+          </a:ln>
+        </c:spPr>
+        <c:txPr>
+          <a:bodyPr/>
+          <a:lstStyle/>
+          <a:p>
+            <a:pPr>
+              <a:defRPr sz="1100" b="0" i="0" u="none" strike="noStrike">
+                <a:solidFill>
+                  <a:srgbClr val="16233D"/>
+                </a:solidFill>
+                <a:latin typeface="Calibri"/>
+              </a:defRPr>
+            </a:pPr>
+            <a:endParaRPr lang="en-US"/>
+          </a:p>
+        </c:txPr>
+        <c:crossAx val="2094734552"/>
+        <c:crosses val="autoZero"/>
+        <c:auto val="1"/>
+        <c:lblAlgn val="ctr"/>
+        <c:noMultiLvlLbl val="1"/>
+      </c:catAx>
+      <c:valAx>
+        <c:axId val="2094734552"/>
+        <c:scaling>
+          <c:orientation val="minMax"/>
+          <c:max val="36000"/>
+          <c:min val="0"/>
+        </c:scaling>
+        <c:delete val="1"/>
+        <c:axPos val="l"/>
+        <c:numFmt formatCode="General" sourceLinked="0"/>
+        <c:majorTickMark val="out"/>
+        <c:minorTickMark val="none"/>
+        <c:tickLblPos val="nextTo"/>
+        <c:spPr>
+          <a:ln w="12700" cap="flat">
+            <a:solidFill>
+              <a:srgbClr val="888888"/>
+            </a:solidFill>
+            <a:prstDash val="solid"/>
+            <a:round/>
+          </a:ln>
+        </c:spPr>
+        <c:txPr>
+          <a:bodyPr/>
+          <a:lstStyle/>
+          <a:p>
+            <a:pPr>
+              <a:defRPr sz="1200" b="0" i="0" u="none" strike="noStrike">
+                <a:solidFill>
+                  <a:srgbClr val="000000"/>
+                </a:solidFill>
+                <a:latin typeface="Arial"/>
+              </a:defRPr>
+            </a:pPr>
+            <a:endParaRPr lang="en-US"/>
+          </a:p>
+        </c:txPr>
+        <c:crossAx val="2094734554"/>
+        <c:crosses val="autoZero"/>
+        <c:crossBetween val="between"/>
+      </c:valAx>
+      <c:spPr>
+        <a:noFill/>
+        <a:ln>
+          <a:noFill/>
+        </a:ln>
+        <a:effectLst/>
+      </c:spPr>
+    </c:plotArea>
+    <c:legend>
+      <c:legendPos val="b"/>
+      <c:overlay val="0"/>
+      <c:txPr>
+        <a:bodyPr/>
+        <a:lstStyle/>
+        <a:p>
+          <a:pPr>
+            <a:defRPr sz="1000">
+              <a:solidFill>
+                <a:srgbClr val="16233D"/>
+              </a:solidFill>
+              <a:latin typeface="Calibri"/>
+              <a:cs typeface="Calibri"/>
+            </a:defRPr>
+          </a:pPr>
+          <a:endParaRPr lang="en-US"/>
+        </a:p>
+      </c:txPr>
+    </c:legend>
+    <c:plotVisOnly val="1"/>
+    <c:dispBlanksAs val="span"/>
+  </c:chart>
+  <c:spPr>
+    <a:noFill/>
+    <a:ln>
+      <a:noFill/>
+    </a:ln>
+    <a:effectLst/>
+  </c:spPr>
+  <c:externalData r:id="rId1">
+    <c:autoUpdate val="0"/>
+  </c:externalData>
+</c:chartSpace>
+</file>
+
+<file path=ppt/charts/chart7.xml><?xml version="1.0" encoding="utf-8"?>
+<c:chartSpace xmlns:c="http://schemas.openxmlformats.org/drawingml/2006/chart" xmlns:a="http://schemas.openxmlformats.org/drawingml/2006/main" xmlns:r="http://schemas.openxmlformats.org/officeDocument/2006/relationships">
+  <c:date1904 val="0"/>
+  <c:roundedCorners val="1"/>
+  <c:chart>
+    <c:title>
+      <c:tx>
+        <c:rich>
+          <a:bodyPr/>
+          <a:lstStyle/>
+          <a:p>
+            <a:pPr>
+              <a:defRPr sz="1200" b="0" i="0" u="none" strike="noStrike">
+                <a:solidFill>
+                  <a:srgbClr val="16233D"/>
+                </a:solidFill>
+                <a:latin typeface="Calibri"/>
+              </a:defRPr>
+            </a:pPr>
+            <a:r>
+              <a:rPr sz="1200" b="0" i="0" u="none" strike="noStrike">
+                <a:solidFill>
+                  <a:srgbClr val="16233D"/>
+                </a:solidFill>
+                <a:latin typeface="Calibri"/>
+              </a:rPr>
+              <a:t>Nano-loan flag by book date (% of customers)</a:t>
+            </a:r>
+          </a:p>
+        </c:rich>
+      </c:tx>
+      <c:layout/>
+      <c:overlay val="0"/>
+    </c:title>
+    <c:autoTitleDeleted val="0"/>
+    <c:plotArea>
+      <c:layout/>
+      <c:barChart>
+        <c:barDir val="col"/>
+        <c:grouping val="percentStacked"/>
+        <c:varyColors val="0"/>
+        <c:ser>
+          <c:idx val="0"/>
+          <c:order val="0"/>
+          <c:tx>
+            <c:strRef>
+              <c:f>Sheet1!$B$1</c:f>
+              <c:strCache>
+                <c:ptCount val="1"/>
+                <c:pt idx="0">
+                  <c:v>N</c:v>
+                </c:pt>
+              </c:strCache>
+            </c:strRef>
+          </c:tx>
+          <c:spPr>
+            <a:solidFill>
+              <a:srgbClr val="8DA0B8"/>
+            </a:solidFill>
+            <a:effectLst/>
+          </c:spPr>
+          <c:invertIfNegative val="0"/>
+          <c:dLbls>
+            <c:numFmt formatCode="0&quot;%&quot;" sourceLinked="0"/>
+            <c:txPr>
+              <a:bodyPr/>
+              <a:lstStyle/>
+              <a:p>
+                <a:pPr>
+                  <a:defRPr b="0" i="0" strike="noStrike" sz="900" u="none">
+                    <a:solidFill>
+                      <a:srgbClr val="FFFFFF"/>
+                    </a:solidFill>
+                    <a:latin typeface="Calibri"/>
+                  </a:defRPr>
+                </a:pPr>
+              </a:p>
+            </c:txPr>
+            <c:dLblPos val="ctr"/>
+            <c:showLegendKey val="0"/>
+            <c:showVal val="1"/>
+            <c:showCatName val="0"/>
+            <c:showSerName val="0"/>
+            <c:showPercent val="0"/>
+            <c:showBubbleSize val="0"/>
+            <c:showLeaderLines val="0"/>
+          </c:dLbls>
+          <c:cat>
+            <c:multiLvlStrRef>
+              <c:f>Sheet1!$A$2:$A$7</c:f>
+              <c:multiLvlStrCache>
+                <c:ptCount val="6"/>
+                <c:lvl>
+                  <c:pt idx="0">
+                    <c:v>bef 1 Aug</c:v>
+                  </c:pt>
+                  <c:pt idx="1">
+                    <c:v>1-Aug</c:v>
+                  </c:pt>
+                  <c:pt idx="2">
+                    <c:v>2-Aug</c:v>
+                  </c:pt>
+                  <c:pt idx="3">
+                    <c:v>3-Aug</c:v>
+                  </c:pt>
+                  <c:pt idx="4">
+                    <c:v>4-Aug</c:v>
+                  </c:pt>
+                  <c:pt idx="5">
+                    <c:v>5-Aug</c:v>
+                  </c:pt>
+                </c:lvl>
+              </c:multiLvlStrCache>
+            </c:multiLvlStrRef>
+          </c:cat>
+          <c:val>
+            <c:numRef>
+              <c:f>Sheet1!$B$2:$B$7</c:f>
+              <c:numCache>
+                <c:formatCode>General</c:formatCode>
+                <c:ptCount val="6"/>
+                <c:pt idx="0">
+                  <c:v>37.1</c:v>
+                </c:pt>
+                <c:pt idx="1">
+                  <c:v>35.2</c:v>
+                </c:pt>
+                <c:pt idx="2">
+                  <c:v>38</c:v>
+                </c:pt>
+                <c:pt idx="3">
+                  <c:v>36.8</c:v>
+                </c:pt>
+                <c:pt idx="4">
+                  <c:v>39.6</c:v>
+                </c:pt>
+                <c:pt idx="5">
+                  <c:v>44.7</c:v>
+                </c:pt>
+              </c:numCache>
+            </c:numRef>
+          </c:val>
+        </c:ser>
+        <c:ser>
+          <c:idx val="1"/>
+          <c:order val="1"/>
+          <c:tx>
+            <c:strRef>
+              <c:f>Sheet1!$C$1</c:f>
+              <c:strCache>
+                <c:ptCount val="1"/>
+                <c:pt idx="0">
+                  <c:v>Y</c:v>
+                </c:pt>
+              </c:strCache>
+            </c:strRef>
+          </c:tx>
+          <c:spPr>
+            <a:solidFill>
+              <a:srgbClr val="165A73"/>
+            </a:solidFill>
+            <a:effectLst/>
+          </c:spPr>
+          <c:invertIfNegative val="0"/>
+          <c:dLbls>
+            <c:numFmt formatCode="0&quot;%&quot;" sourceLinked="0"/>
+            <c:txPr>
+              <a:bodyPr/>
+              <a:lstStyle/>
+              <a:p>
+                <a:pPr>
+                  <a:defRPr b="0" i="0" strike="noStrike" sz="900" u="none">
+                    <a:solidFill>
+                      <a:srgbClr val="FFFFFF"/>
+                    </a:solidFill>
+                    <a:latin typeface="Calibri"/>
+                  </a:defRPr>
+                </a:pPr>
+              </a:p>
+            </c:txPr>
+            <c:dLblPos val="ctr"/>
+            <c:showLegendKey val="0"/>
+            <c:showVal val="1"/>
+            <c:showCatName val="0"/>
+            <c:showSerName val="0"/>
+            <c:showPercent val="0"/>
+            <c:showBubbleSize val="0"/>
+            <c:showLeaderLines val="0"/>
+          </c:dLbls>
+          <c:cat>
+            <c:multiLvlStrRef>
+              <c:f>Sheet1!$A$2:$A$7</c:f>
+              <c:multiLvlStrCache>
+                <c:ptCount val="6"/>
+                <c:lvl>
+                  <c:pt idx="0">
+                    <c:v>bef 1 Aug</c:v>
+                  </c:pt>
+                  <c:pt idx="1">
+                    <c:v>1-Aug</c:v>
+                  </c:pt>
+                  <c:pt idx="2">
+                    <c:v>2-Aug</c:v>
+                  </c:pt>
+                  <c:pt idx="3">
+                    <c:v>3-Aug</c:v>
+                  </c:pt>
+                  <c:pt idx="4">
+                    <c:v>4-Aug</c:v>
+                  </c:pt>
+                  <c:pt idx="5">
+                    <c:v>5-Aug</c:v>
+                  </c:pt>
+                </c:lvl>
+              </c:multiLvlStrCache>
+            </c:multiLvlStrRef>
+          </c:cat>
+          <c:val>
+            <c:numRef>
+              <c:f>Sheet1!$C$2:$C$7</c:f>
+              <c:numCache>
+                <c:formatCode>General</c:formatCode>
+                <c:ptCount val="6"/>
+                <c:pt idx="0">
+                  <c:v>62.9</c:v>
+                </c:pt>
+                <c:pt idx="1">
+                  <c:v>64.8</c:v>
+                </c:pt>
+                <c:pt idx="2">
+                  <c:v>62</c:v>
+                </c:pt>
+                <c:pt idx="3">
+                  <c:v>63.2</c:v>
+                </c:pt>
+                <c:pt idx="4">
+                  <c:v>60.4</c:v>
+                </c:pt>
+                <c:pt idx="5">
+                  <c:v>55.3</c:v>
+                </c:pt>
+              </c:numCache>
+            </c:numRef>
+          </c:val>
+        </c:ser>
+        <c:dLbls>
+          <c:numFmt formatCode="0&quot;%&quot;" sourceLinked="0"/>
+          <c:txPr>
+            <a:bodyPr/>
+            <a:lstStyle/>
+            <a:p>
+              <a:pPr>
+                <a:defRPr b="0" i="0" strike="noStrike" sz="900" u="none">
+                  <a:solidFill>
+                    <a:srgbClr val="FFFFFF"/>
+                  </a:solidFill>
+                  <a:latin typeface="Calibri"/>
+                </a:defRPr>
+              </a:pPr>
+            </a:p>
+          </c:txPr>
+          <c:dLblPos val="ctr"/>
+          <c:showLegendKey val="0"/>
+          <c:showVal val="1"/>
+          <c:showCatName val="0"/>
+          <c:showSerName val="0"/>
+          <c:showPercent val="0"/>
+          <c:showBubbleSize val="0"/>
+          <c:showLeaderLines val="0"/>
+        </c:dLbls>
+        <c:gapWidth val="45"/>
+        <c:overlap val="100"/>
+        <c:axId val="2094734554"/>
+        <c:axId val="2094734552"/>
+        <c:axId val="2094734556"/>
+      </c:barChart>
+      <c:catAx>
+        <c:axId val="2094734554"/>
+        <c:scaling>
+          <c:orientation val="minMax"/>
+        </c:scaling>
+        <c:delete val="0"/>
+        <c:axPos val="b"/>
+        <c:numFmt formatCode="General" sourceLinked="1"/>
+        <c:majorTickMark val="out"/>
+        <c:minorTickMark val="none"/>
+        <c:tickLblPos val="low"/>
+        <c:spPr>
+          <a:ln w="12700" cap="flat">
+            <a:solidFill>
+              <a:srgbClr val="888888"/>
+            </a:solidFill>
+            <a:prstDash val="solid"/>
+            <a:round/>
+          </a:ln>
+        </c:spPr>
+        <c:txPr>
+          <a:bodyPr/>
+          <a:lstStyle/>
+          <a:p>
+            <a:pPr>
+              <a:defRPr sz="1000" b="0" i="0" u="none" strike="noStrike">
+                <a:solidFill>
+                  <a:srgbClr val="16233D"/>
+                </a:solidFill>
+                <a:latin typeface="Calibri"/>
+              </a:defRPr>
+            </a:pPr>
+            <a:endParaRPr lang="en-US"/>
+          </a:p>
+        </c:txPr>
+        <c:crossAx val="2094734552"/>
+        <c:crosses val="autoZero"/>
+        <c:auto val="1"/>
+        <c:lblAlgn val="ctr"/>
+        <c:noMultiLvlLbl val="1"/>
+      </c:catAx>
+      <c:valAx>
+        <c:axId val="2094734552"/>
+        <c:scaling>
+          <c:orientation val="minMax"/>
+        </c:scaling>
+        <c:delete val="1"/>
+        <c:axPos val="l"/>
+        <c:numFmt formatCode="General" sourceLinked="0"/>
+        <c:majorTickMark val="out"/>
+        <c:minorTickMark val="none"/>
+        <c:tickLblPos val="nextTo"/>
+        <c:spPr>
+          <a:ln w="12700" cap="flat">
+            <a:solidFill>
+              <a:srgbClr val="888888"/>
+            </a:solidFill>
+            <a:prstDash val="solid"/>
+            <a:round/>
+          </a:ln>
+        </c:spPr>
+        <c:txPr>
+          <a:bodyPr/>
+          <a:lstStyle/>
+          <a:p>
+            <a:pPr>
+              <a:defRPr sz="1200" b="0" i="0" u="none" strike="noStrike">
+                <a:solidFill>
+                  <a:srgbClr val="000000"/>
+                </a:solidFill>
+                <a:latin typeface="Arial"/>
+              </a:defRPr>
+            </a:pPr>
+            <a:endParaRPr lang="en-US"/>
+          </a:p>
+        </c:txPr>
+        <c:crossAx val="2094734554"/>
+        <c:crosses val="autoZero"/>
+        <c:crossBetween val="between"/>
+      </c:valAx>
+      <c:spPr>
+        <a:noFill/>
+        <a:ln>
+          <a:noFill/>
+        </a:ln>
+        <a:effectLst/>
+      </c:spPr>
+    </c:plotArea>
+    <c:legend>
+      <c:legendPos val="b"/>
+      <c:overlay val="0"/>
+      <c:txPr>
+        <a:bodyPr/>
+        <a:lstStyle/>
+        <a:p>
+          <a:pPr>
+            <a:defRPr sz="1000">
+              <a:solidFill>
+                <a:srgbClr val="16233D"/>
+              </a:solidFill>
+              <a:latin typeface="Calibri"/>
+              <a:cs typeface="Calibri"/>
+            </a:defRPr>
+          </a:pPr>
+          <a:endParaRPr lang="en-US"/>
+        </a:p>
+      </c:txPr>
+    </c:legend>
+    <c:plotVisOnly val="1"/>
+    <c:dispBlanksAs val="span"/>
+  </c:chart>
+  <c:spPr>
+    <a:noFill/>
+    <a:ln>
+      <a:noFill/>
+    </a:ln>
+    <a:effectLst/>
+  </c:spPr>
+  <c:externalData r:id="rId1">
+    <c:autoUpdate val="0"/>
+  </c:externalData>
+</c:chartSpace>
+</file>
+
+<file path=ppt/charts/chart8.xml><?xml version="1.0" encoding="utf-8"?>
+<c:chartSpace xmlns:c="http://schemas.openxmlformats.org/drawingml/2006/chart" xmlns:a="http://schemas.openxmlformats.org/drawingml/2006/main" xmlns:r="http://schemas.openxmlformats.org/officeDocument/2006/relationships">
+  <c:date1904 val="0"/>
+  <c:roundedCorners val="1"/>
+  <c:chart>
+    <c:title>
+      <c:tx>
+        <c:rich>
+          <a:bodyPr/>
+          <a:lstStyle/>
+          <a:p>
+            <a:pPr>
+              <a:defRPr sz="1200" b="0" i="0" u="none" strike="noStrike">
+                <a:solidFill>
+                  <a:srgbClr val="16233D"/>
+                </a:solidFill>
+                <a:latin typeface="Calibri"/>
+              </a:defRPr>
+            </a:pPr>
+            <a:r>
+              <a:rPr sz="1200" b="0" i="0" u="none" strike="noStrike">
+                <a:solidFill>
+                  <a:srgbClr val="16233D"/>
+                </a:solidFill>
+                <a:latin typeface="Calibri"/>
+              </a:rPr>
+              <a:t>TRUE ecosystem by book date (% of customers)</a:t>
+            </a:r>
+          </a:p>
+        </c:rich>
+      </c:tx>
+      <c:layout/>
+      <c:overlay val="0"/>
+    </c:title>
+    <c:autoTitleDeleted val="0"/>
+    <c:plotArea>
+      <c:layout/>
+      <c:barChart>
+        <c:barDir val="col"/>
+        <c:grouping val="percentStacked"/>
+        <c:varyColors val="0"/>
+        <c:ser>
+          <c:idx val="0"/>
+          <c:order val="0"/>
+          <c:tx>
+            <c:strRef>
+              <c:f>Sheet1!$B$1</c:f>
+              <c:strCache>
+                <c:ptCount val="1"/>
+                <c:pt idx="0">
+                  <c:v>N</c:v>
+                </c:pt>
+              </c:strCache>
+            </c:strRef>
+          </c:tx>
+          <c:spPr>
+            <a:solidFill>
+              <a:srgbClr val="8DA0B8"/>
+            </a:solidFill>
+            <a:effectLst/>
+          </c:spPr>
+          <c:invertIfNegative val="0"/>
+          <c:dLbls>
+            <c:numFmt formatCode="0&quot;%&quot;" sourceLinked="0"/>
+            <c:txPr>
+              <a:bodyPr/>
+              <a:lstStyle/>
+              <a:p>
+                <a:pPr>
+                  <a:defRPr b="0" i="0" strike="noStrike" sz="900" u="none">
+                    <a:solidFill>
+                      <a:srgbClr val="FFFFFF"/>
+                    </a:solidFill>
+                    <a:latin typeface="Calibri"/>
+                  </a:defRPr>
+                </a:pPr>
+              </a:p>
+            </c:txPr>
+            <c:dLblPos val="ctr"/>
+            <c:showLegendKey val="0"/>
+            <c:showVal val="1"/>
+            <c:showCatName val="0"/>
+            <c:showSerName val="0"/>
+            <c:showPercent val="0"/>
+            <c:showBubbleSize val="0"/>
+            <c:showLeaderLines val="0"/>
+          </c:dLbls>
+          <c:cat>
+            <c:multiLvlStrRef>
+              <c:f>Sheet1!$A$2:$A$7</c:f>
+              <c:multiLvlStrCache>
+                <c:ptCount val="6"/>
+                <c:lvl>
+                  <c:pt idx="0">
+                    <c:v>bef 1 Aug</c:v>
+                  </c:pt>
+                  <c:pt idx="1">
+                    <c:v>1-Aug</c:v>
+                  </c:pt>
+                  <c:pt idx="2">
+                    <c:v>2-Aug</c:v>
+                  </c:pt>
+                  <c:pt idx="3">
+                    <c:v>3-Aug</c:v>
+                  </c:pt>
+                  <c:pt idx="4">
+                    <c:v>4-Aug</c:v>
+                  </c:pt>
+                  <c:pt idx="5">
+                    <c:v>5-Aug</c:v>
+                  </c:pt>
+                </c:lvl>
+              </c:multiLvlStrCache>
+            </c:multiLvlStrRef>
+          </c:cat>
+          <c:val>
+            <c:numRef>
+              <c:f>Sheet1!$B$2:$B$7</c:f>
+              <c:numCache>
+                <c:formatCode>General</c:formatCode>
+                <c:ptCount val="6"/>
+                <c:pt idx="0">
+                  <c:v>18.1</c:v>
+                </c:pt>
+                <c:pt idx="1">
+                  <c:v>29.7</c:v>
+                </c:pt>
+                <c:pt idx="2">
+                  <c:v>31.9</c:v>
+                </c:pt>
+                <c:pt idx="3">
+                  <c:v>31.3</c:v>
+                </c:pt>
+                <c:pt idx="4">
+                  <c:v>32.7</c:v>
+                </c:pt>
+                <c:pt idx="5">
+                  <c:v>33.4</c:v>
+                </c:pt>
+              </c:numCache>
+            </c:numRef>
+          </c:val>
+        </c:ser>
+        <c:ser>
+          <c:idx val="1"/>
+          <c:order val="1"/>
+          <c:tx>
+            <c:strRef>
+              <c:f>Sheet1!$C$1</c:f>
+              <c:strCache>
+                <c:ptCount val="1"/>
+                <c:pt idx="0">
+                  <c:v>Y</c:v>
+                </c:pt>
+              </c:strCache>
+            </c:strRef>
+          </c:tx>
+          <c:spPr>
+            <a:solidFill>
+              <a:srgbClr val="165A73"/>
+            </a:solidFill>
+            <a:effectLst/>
+          </c:spPr>
+          <c:invertIfNegative val="0"/>
+          <c:dLbls>
+            <c:numFmt formatCode="0&quot;%&quot;" sourceLinked="0"/>
+            <c:txPr>
+              <a:bodyPr/>
+              <a:lstStyle/>
+              <a:p>
+                <a:pPr>
+                  <a:defRPr b="0" i="0" strike="noStrike" sz="900" u="none">
+                    <a:solidFill>
+                      <a:srgbClr val="FFFFFF"/>
+                    </a:solidFill>
+                    <a:latin typeface="Calibri"/>
+                  </a:defRPr>
+                </a:pPr>
+              </a:p>
+            </c:txPr>
+            <c:dLblPos val="ctr"/>
+            <c:showLegendKey val="0"/>
+            <c:showVal val="1"/>
+            <c:showCatName val="0"/>
+            <c:showSerName val="0"/>
+            <c:showPercent val="0"/>
+            <c:showBubbleSize val="0"/>
+            <c:showLeaderLines val="0"/>
+          </c:dLbls>
+          <c:cat>
+            <c:multiLvlStrRef>
+              <c:f>Sheet1!$A$2:$A$7</c:f>
+              <c:multiLvlStrCache>
+                <c:ptCount val="6"/>
+                <c:lvl>
+                  <c:pt idx="0">
+                    <c:v>bef 1 Aug</c:v>
+                  </c:pt>
+                  <c:pt idx="1">
+                    <c:v>1-Aug</c:v>
+                  </c:pt>
+                  <c:pt idx="2">
+                    <c:v>2-Aug</c:v>
+                  </c:pt>
+                  <c:pt idx="3">
+                    <c:v>3-Aug</c:v>
+                  </c:pt>
+                  <c:pt idx="4">
+                    <c:v>4-Aug</c:v>
+                  </c:pt>
+                  <c:pt idx="5">
+                    <c:v>5-Aug</c:v>
+                  </c:pt>
+                </c:lvl>
+              </c:multiLvlStrCache>
+            </c:multiLvlStrRef>
+          </c:cat>
+          <c:val>
+            <c:numRef>
+              <c:f>Sheet1!$C$2:$C$7</c:f>
+              <c:numCache>
+                <c:formatCode>General</c:formatCode>
+                <c:ptCount val="6"/>
+                <c:pt idx="0">
+                  <c:v>81.9</c:v>
+                </c:pt>
+                <c:pt idx="1">
+                  <c:v>70.3</c:v>
+                </c:pt>
+                <c:pt idx="2">
+                  <c:v>68.1</c:v>
+                </c:pt>
+                <c:pt idx="3">
+                  <c:v>68.7</c:v>
+                </c:pt>
+                <c:pt idx="4">
+                  <c:v>67.3</c:v>
+                </c:pt>
+                <c:pt idx="5">
+                  <c:v>66.6</c:v>
+                </c:pt>
+              </c:numCache>
+            </c:numRef>
+          </c:val>
+        </c:ser>
+        <c:dLbls>
+          <c:numFmt formatCode="0&quot;%&quot;" sourceLinked="0"/>
+          <c:txPr>
+            <a:bodyPr/>
+            <a:lstStyle/>
+            <a:p>
+              <a:pPr>
+                <a:defRPr b="0" i="0" strike="noStrike" sz="900" u="none">
+                  <a:solidFill>
+                    <a:srgbClr val="FFFFFF"/>
+                  </a:solidFill>
+                  <a:latin typeface="Calibri"/>
+                </a:defRPr>
+              </a:pPr>
+            </a:p>
+          </c:txPr>
+          <c:dLblPos val="ctr"/>
+          <c:showLegendKey val="0"/>
+          <c:showVal val="1"/>
+          <c:showCatName val="0"/>
+          <c:showSerName val="0"/>
+          <c:showPercent val="0"/>
+          <c:showBubbleSize val="0"/>
+          <c:showLeaderLines val="0"/>
+        </c:dLbls>
+        <c:gapWidth val="45"/>
+        <c:overlap val="100"/>
+        <c:axId val="2094734554"/>
+        <c:axId val="2094734552"/>
+        <c:axId val="2094734556"/>
+      </c:barChart>
+      <c:catAx>
+        <c:axId val="2094734554"/>
+        <c:scaling>
+          <c:orientation val="minMax"/>
+        </c:scaling>
+        <c:delete val="0"/>
+        <c:axPos val="b"/>
+        <c:numFmt formatCode="General" sourceLinked="1"/>
+        <c:majorTickMark val="out"/>
+        <c:minorTickMark val="none"/>
+        <c:tickLblPos val="low"/>
+        <c:spPr>
+          <a:ln w="12700" cap="flat">
+            <a:solidFill>
+              <a:srgbClr val="888888"/>
+            </a:solidFill>
+            <a:prstDash val="solid"/>
+            <a:round/>
+          </a:ln>
+        </c:spPr>
+        <c:txPr>
+          <a:bodyPr/>
+          <a:lstStyle/>
+          <a:p>
+            <a:pPr>
+              <a:defRPr sz="1000" b="0" i="0" u="none" strike="noStrike">
+                <a:solidFill>
+                  <a:srgbClr val="16233D"/>
+                </a:solidFill>
+                <a:latin typeface="Calibri"/>
+              </a:defRPr>
+            </a:pPr>
+            <a:endParaRPr lang="en-US"/>
+          </a:p>
+        </c:txPr>
+        <c:crossAx val="2094734552"/>
+        <c:crosses val="autoZero"/>
+        <c:auto val="1"/>
+        <c:lblAlgn val="ctr"/>
+        <c:noMultiLvlLbl val="1"/>
+      </c:catAx>
+      <c:valAx>
+        <c:axId val="2094734552"/>
+        <c:scaling>
+          <c:orientation val="minMax"/>
+        </c:scaling>
+        <c:delete val="1"/>
+        <c:axPos val="l"/>
+        <c:numFmt formatCode="General" sourceLinked="0"/>
+        <c:majorTickMark val="out"/>
+        <c:minorTickMark val="none"/>
+        <c:tickLblPos val="nextTo"/>
         <c:spPr>
           <a:ln w="12700" cap="flat">
             <a:solidFill>
@@ -2735,6 +3935,94 @@
             <a:fld id="{F7021451-1387-4CA6-816F-3879F97B5CBC}" type="slidenum">
               <a:rPr lang="en-US"/>
               <a:t>2</a:t>
+            </a:fld>
+            <a:endParaRPr lang="en-US"/>
+          </a:p>
+        </p:txBody>
+      </p:sp>
+    </p:spTree>
+    <p:extLst>
+      <p:ext uri="{BB962C8B-B14F-4D97-AF65-F5344CB8AC3E}">
+        <p14:creationId xmlns:p14="http://schemas.microsoft.com/office/powerpoint/2010/main" val="1024086991"/>
+      </p:ext>
+    </p:extLst>
+  </p:cSld>
+  <p:clrMapOvr>
+    <a:masterClrMapping/>
+  </p:clrMapOvr>
+</p:notes>
+</file>
+
+<file path=ppt/notesSlides/notesSlide3.xml><?xml version="1.0" encoding="utf-8"?>
+<p:notes xmlns:a="http://schemas.openxmlformats.org/drawingml/2006/main" xmlns:r="http://schemas.openxmlformats.org/officeDocument/2006/relationships" xmlns:p="http://schemas.openxmlformats.org/presentationml/2006/main">
+  <p:cSld>
+    <p:spTree>
+      <p:nvGrpSpPr>
+        <p:cNvPr id="1" name=""/>
+        <p:cNvGrpSpPr/>
+        <p:nvPr/>
+      </p:nvGrpSpPr>
+      <p:grpSpPr>
+        <a:xfrm>
+          <a:off x="0" y="0"/>
+          <a:ext cx="0" cy="0"/>
+          <a:chOff x="0" y="0"/>
+          <a:chExt cx="0" cy="0"/>
+        </a:xfrm>
+      </p:grpSpPr>
+      <p:sp>
+        <p:nvSpPr>
+          <p:cNvPr id="2" name="Slide Image Placeholder 1"/>
+          <p:cNvSpPr>
+            <a:spLocks noGrp="1" noRot="1" noChangeAspect="1"/>
+          </p:cNvSpPr>
+          <p:nvPr>
+            <p:ph type="sldImg"/>
+          </p:nvPr>
+        </p:nvSpPr>
+        <p:spPr/>
+      </p:sp>
+      <p:sp>
+        <p:nvSpPr>
+          <p:cNvPr id="3" name="Notes Placeholder 2"/>
+          <p:cNvSpPr>
+            <a:spLocks noGrp="1"/>
+          </p:cNvSpPr>
+          <p:nvPr>
+            <p:ph type="body" idx="1"/>
+          </p:nvPr>
+        </p:nvSpPr>
+        <p:spPr/>
+        <p:txBody>
+          <a:bodyPr/>
+          <a:lstStyle/>
+          <a:p>
+            <a:r>
+              <a:rPr lang="en-US" dirty="0"/>
+              <a:t>2 Aug alone accounts for 33,341 of the 70,100 AIS bookings (47.6%). PL is back-loaded: 4,255 of its 6,340 bookings (67%) land on 5 Aug. Nano-loan Y falls from 64.8% on 1 Aug to 55.3% on 5 Aug, a 9.5 point drop, and the PL surge on 5 Aug is part of why - PL runs a lower nano share than DL. TRUE Y drifts down more gently, 70.3% to 66.6%. Charge type and tenure are effectively flat across the same window.</a:t>
+            </a:r>
+            <a:endParaRPr lang="en-US" dirty="0"/>
+          </a:p>
+        </p:txBody>
+      </p:sp>
+      <p:sp>
+        <p:nvSpPr>
+          <p:cNvPr id="4" name="Slide Number Placeholder 3"/>
+          <p:cNvSpPr>
+            <a:spLocks noGrp="1"/>
+          </p:cNvSpPr>
+          <p:nvPr>
+            <p:ph type="sldNum" sz="quarter" idx="10"/>
+          </p:nvPr>
+        </p:nvSpPr>
+        <p:spPr/>
+        <p:txBody>
+          <a:bodyPr/>
+          <a:lstStyle/>
+          <a:p>
+            <a:fld id="{F7021451-1387-4CA6-816F-3879F97B5CBC}" type="slidenum">
+              <a:rPr lang="en-US"/>
+              <a:t>3</a:t>
             </a:fld>
             <a:endParaRPr lang="en-US"/>
           </a:p>
@@ -4857,6 +6145,308 @@
 </p:sld>
 </file>
 
+<file path=ppt/slides/slide3.xml><?xml version="1.0" encoding="utf-8"?>
+<p:sld xmlns:a="http://schemas.openxmlformats.org/drawingml/2006/main" xmlns:r="http://schemas.openxmlformats.org/officeDocument/2006/relationships" xmlns:p="http://schemas.openxmlformats.org/presentationml/2006/main">
+  <p:cSld name="Slide 3">
+    <p:bg>
+      <p:bgPr>
+        <a:solidFill>
+          <a:srgbClr val="FFFFFF"/>
+        </a:solidFill>
+      </p:bgPr>
+    </p:bg>
+    <p:spTree>
+      <p:nvGrpSpPr>
+        <p:cNvPr id="1" name=""/>
+        <p:cNvGrpSpPr/>
+        <p:nvPr/>
+      </p:nvGrpSpPr>
+      <p:grpSpPr>
+        <a:xfrm>
+          <a:off x="0" y="0"/>
+          <a:ext cx="0" cy="0"/>
+          <a:chOff x="0" y="0"/>
+          <a:chExt cx="0" cy="0"/>
+        </a:xfrm>
+      </p:grpSpPr>
+      <p:sp>
+        <p:nvSpPr>
+          <p:cNvPr id="2" name="Text 0"/>
+          <p:cNvSpPr/>
+          <p:nvPr/>
+        </p:nvSpPr>
+        <p:spPr>
+          <a:xfrm>
+            <a:off x="548640" y="329184"/>
+            <a:ext cx="11064240" cy="237744"/>
+          </a:xfrm>
+          <a:prstGeom prst="rect">
+            <a:avLst/>
+          </a:prstGeom>
+          <a:noFill/>
+          <a:ln/>
+        </p:spPr>
+        <p:txBody>
+          <a:bodyPr wrap="square" lIns="0" tIns="0" rIns="0" bIns="0" rtlCol="0" anchor="ctr"/>
+          <a:lstStyle/>
+          <a:p>
+            <a:pPr indent="0" marL="0">
+              <a:buNone/>
+            </a:pPr>
+            <a:r>
+              <a:rPr lang="en-US" sz="1150" b="1" spc="220" kern="0" dirty="0">
+                <a:solidFill>
+                  <a:srgbClr val="00A896"/>
+                </a:solidFill>
+                <a:latin typeface="Calibri" pitchFamily="34" charset="0"/>
+                <a:ea typeface="Calibri" pitchFamily="34" charset="-122"/>
+                <a:cs typeface="Calibri" pitchFamily="34" charset="-120"/>
+              </a:rPr>
+              <a:t>AIS BASE INFORMATION  ·  BY BOOK DATE</a:t>
+            </a:r>
+            <a:endParaRPr lang="en-US" sz="1150" dirty="0"/>
+          </a:p>
+        </p:txBody>
+      </p:sp>
+      <p:sp>
+        <p:nvSpPr>
+          <p:cNvPr id="3" name="Text 1"/>
+          <p:cNvSpPr/>
+          <p:nvPr/>
+        </p:nvSpPr>
+        <p:spPr>
+          <a:xfrm>
+            <a:off x="548640" y="603504"/>
+            <a:ext cx="11064240" cy="566928"/>
+          </a:xfrm>
+          <a:prstGeom prst="rect">
+            <a:avLst/>
+          </a:prstGeom>
+          <a:noFill/>
+          <a:ln/>
+        </p:spPr>
+        <p:txBody>
+          <a:bodyPr wrap="square" lIns="0" tIns="0" rIns="0" bIns="0" rtlCol="0" anchor="t"/>
+          <a:lstStyle/>
+          <a:p>
+            <a:pPr indent="0" marL="0">
+              <a:buNone/>
+            </a:pPr>
+            <a:r>
+              <a:rPr lang="en-US" sz="3200" b="1" dirty="0">
+                <a:solidFill>
+                  <a:srgbClr val="16233D"/>
+                </a:solidFill>
+                <a:latin typeface="Cambria" pitchFamily="34" charset="0"/>
+                <a:ea typeface="Cambria" pitchFamily="34" charset="-122"/>
+                <a:cs typeface="Cambria" pitchFamily="34" charset="-120"/>
+              </a:rPr>
+              <a:t>Nearly half the base booked on 2 August</a:t>
+            </a:r>
+            <a:endParaRPr lang="en-US" sz="3200" dirty="0"/>
+          </a:p>
+        </p:txBody>
+      </p:sp>
+      <p:sp>
+        <p:nvSpPr>
+          <p:cNvPr id="4" name="Text 2"/>
+          <p:cNvSpPr/>
+          <p:nvPr/>
+        </p:nvSpPr>
+        <p:spPr>
+          <a:xfrm>
+            <a:off x="548640" y="1097280"/>
+            <a:ext cx="11064240" cy="256032"/>
+          </a:xfrm>
+          <a:prstGeom prst="rect">
+            <a:avLst/>
+          </a:prstGeom>
+          <a:noFill/>
+          <a:ln/>
+        </p:spPr>
+        <p:txBody>
+          <a:bodyPr wrap="square" lIns="0" tIns="0" rIns="0" bIns="0" rtlCol="0" anchor="t"/>
+          <a:lstStyle/>
+          <a:p>
+            <a:pPr indent="0" marL="0">
+              <a:buNone/>
+            </a:pPr>
+            <a:r>
+              <a:rPr lang="en-US" sz="1250" dirty="0">
+                <a:solidFill>
+                  <a:srgbClr val="6B7A90"/>
+                </a:solidFill>
+                <a:latin typeface="Calibri" pitchFamily="34" charset="0"/>
+                <a:ea typeface="Calibri" pitchFamily="34" charset="-122"/>
+                <a:cs typeface="Calibri" pitchFamily="34" charset="-120"/>
+              </a:rPr>
+              <a:t>PL arrives almost entirely on 5 Aug, and each later cohort is a little less nano-loan — the flag falls 9.5 points from 1 to 5 Aug.</a:t>
+            </a:r>
+            <a:endParaRPr lang="en-US" sz="1250" dirty="0"/>
+          </a:p>
+        </p:txBody>
+      </p:sp>
+      <p:sp>
+        <p:nvSpPr>
+          <p:cNvPr id="5" name="Shape 3"/>
+          <p:cNvSpPr/>
+          <p:nvPr/>
+        </p:nvSpPr>
+        <p:spPr>
+          <a:xfrm>
+            <a:off x="548640" y="1426464"/>
+            <a:ext cx="11064240" cy="2139696"/>
+          </a:xfrm>
+          <a:prstGeom prst="roundRect">
+            <a:avLst>
+              <a:gd name="adj" fmla="val 3846"/>
+            </a:avLst>
+          </a:prstGeom>
+          <a:solidFill>
+            <a:srgbClr val="F1F4F9"/>
+          </a:solidFill>
+          <a:ln/>
+        </p:spPr>
+      </p:sp>
+      <p:graphicFrame>
+        <p:nvGraphicFramePr>
+          <p:cNvPr id="6" name="Chart 0" descr=""/>
+          <p:cNvGraphicFramePr/>
+          <p:nvPr/>
+        </p:nvGraphicFramePr>
+        <p:xfrm>
+          <a:off x="658368" y="1517904"/>
+          <a:ext cx="10844784" cy="1956816"/>
+        </p:xfrm>
+        <a:graphic xmlns:a="http://schemas.openxmlformats.org/drawingml/2006/main">
+          <a:graphicData uri="http://schemas.openxmlformats.org/drawingml/2006/chart">
+            <c:chart xmlns:c="http://schemas.openxmlformats.org/drawingml/2006/chart" r:id="rId1"/>
+          </a:graphicData>
+        </a:graphic>
+      </p:graphicFrame>
+      <p:sp>
+        <p:nvSpPr>
+          <p:cNvPr id="7" name="Shape 4"/>
+          <p:cNvSpPr/>
+          <p:nvPr/>
+        </p:nvSpPr>
+        <p:spPr>
+          <a:xfrm>
+            <a:off x="548640" y="3712464"/>
+            <a:ext cx="5440680" cy="2249424"/>
+          </a:xfrm>
+          <a:prstGeom prst="roundRect">
+            <a:avLst>
+              <a:gd name="adj" fmla="val 3659"/>
+            </a:avLst>
+          </a:prstGeom>
+          <a:solidFill>
+            <a:srgbClr val="F1F4F9"/>
+          </a:solidFill>
+          <a:ln/>
+        </p:spPr>
+      </p:sp>
+      <p:graphicFrame>
+        <p:nvGraphicFramePr>
+          <p:cNvPr id="8" name="Chart 1" descr=""/>
+          <p:cNvGraphicFramePr/>
+          <p:nvPr/>
+        </p:nvGraphicFramePr>
+        <p:xfrm>
+          <a:off x="658368" y="3803904"/>
+          <a:ext cx="5221224" cy="2066544"/>
+        </p:xfrm>
+        <a:graphic xmlns:a="http://schemas.openxmlformats.org/drawingml/2006/main">
+          <a:graphicData uri="http://schemas.openxmlformats.org/drawingml/2006/chart">
+            <c:chart xmlns:c="http://schemas.openxmlformats.org/drawingml/2006/chart" r:id="rId2"/>
+          </a:graphicData>
+        </a:graphic>
+      </p:graphicFrame>
+      <p:sp>
+        <p:nvSpPr>
+          <p:cNvPr id="9" name="Shape 5"/>
+          <p:cNvSpPr/>
+          <p:nvPr/>
+        </p:nvSpPr>
+        <p:spPr>
+          <a:xfrm>
+            <a:off x="6172200" y="3712464"/>
+            <a:ext cx="5440680" cy="2249424"/>
+          </a:xfrm>
+          <a:prstGeom prst="roundRect">
+            <a:avLst>
+              <a:gd name="adj" fmla="val 3659"/>
+            </a:avLst>
+          </a:prstGeom>
+          <a:solidFill>
+            <a:srgbClr val="F1F4F9"/>
+          </a:solidFill>
+          <a:ln/>
+        </p:spPr>
+      </p:sp>
+      <p:graphicFrame>
+        <p:nvGraphicFramePr>
+          <p:cNvPr id="10" name="Chart 2" descr=""/>
+          <p:cNvGraphicFramePr/>
+          <p:nvPr/>
+        </p:nvGraphicFramePr>
+        <p:xfrm>
+          <a:off x="6281928" y="3803904"/>
+          <a:ext cx="5221224" cy="2066544"/>
+        </p:xfrm>
+        <a:graphic xmlns:a="http://schemas.openxmlformats.org/drawingml/2006/main">
+          <a:graphicData uri="http://schemas.openxmlformats.org/drawingml/2006/chart">
+            <c:chart xmlns:c="http://schemas.openxmlformats.org/drawingml/2006/chart" r:id="rId3"/>
+          </a:graphicData>
+        </a:graphic>
+      </p:graphicFrame>
+      <p:sp>
+        <p:nvSpPr>
+          <p:cNvPr id="11" name="Text 6"/>
+          <p:cNvSpPr/>
+          <p:nvPr/>
+        </p:nvSpPr>
+        <p:spPr>
+          <a:xfrm>
+            <a:off x="548640" y="6089904"/>
+            <a:ext cx="11064240" cy="512064"/>
+          </a:xfrm>
+          <a:prstGeom prst="rect">
+            <a:avLst/>
+          </a:prstGeom>
+          <a:noFill/>
+          <a:ln/>
+        </p:spPr>
+        <p:txBody>
+          <a:bodyPr wrap="square" lIns="0" tIns="0" rIns="0" bIns="0" rtlCol="0" anchor="ctr"/>
+          <a:lstStyle/>
+          <a:p>
+            <a:pPr indent="0" marL="0">
+              <a:buNone/>
+            </a:pPr>
+            <a:r>
+              <a:rPr lang="en-US" sz="900" i="1" dirty="0">
+                <a:solidFill>
+                  <a:srgbClr val="6B7A90"/>
+                </a:solidFill>
+                <a:latin typeface="Calibri" pitchFamily="34" charset="0"/>
+                <a:ea typeface="Calibri" pitchFamily="34" charset="-122"/>
+                <a:cs typeface="Calibri" pitchFamily="34" charset="-120"/>
+              </a:rPr>
+              <a:t>Source: Lending_2026.08.07.pptx, AIS Base Information slides. Volumes are the grand totals per book date; the two mixes combine DL and PL. 'bef 1 Aug' holds only 708 customers, so its mix is a small-sample outlier. Charge type and tenure barely move across the August dates (prepaid 46–55%, tenure 5+ years 65–68%) and are shown by loan type on the previous slide.</a:t>
+            </a:r>
+            <a:endParaRPr lang="en-US" sz="900" dirty="0"/>
+          </a:p>
+        </p:txBody>
+      </p:sp>
+    </p:spTree>
+  </p:cSld>
+  <p:clrMapOvr>
+    <a:masterClrMapping/>
+  </p:clrMapOvr>
+</p:sld>
+</file>
+
 <file path=ppt/theme/theme1.xml><?xml version="1.0" encoding="utf-8"?>
 <a:theme xmlns:a="http://schemas.openxmlformats.org/drawingml/2006/main" name="Office Theme">
   <a:themeElements>

</xml_diff>

<commit_message>
Chart charge type and tenure by book date
Adds a fourth slide completing the by-book-date view: charge type and
tenure as percent-stacked columns on the same date axis as the nano-loan
and TRUE charts, with a band quantifying how little each mix moves
(prepaid 8.6pt, tenure 3.3pt, against 9.5pt for the nano-loan flag).

Updates the slide 3 footnote, which previously said these two were only
shown by loan type.

Co-Authored-By: Claude Opus 5 <noreply@anthropic.com>
Claude-Session: https://claude.ai/code/session_01VKpfo226Go9vQJYa4eoC1d
</commit_message>
<xml_diff>
--- a/Lending_Book_Loan_Summary.pptx
+++ b/Lending_Book_Loan_Summary.pptx
@@ -8,9 +8,10 @@
     <p:sldId id="256" r:id="rId2"/>
     <p:sldId id="257" r:id="rId3"/>
     <p:sldId id="258" r:id="rId4"/>
+    <p:sldId id="259" r:id="rId5"/>
   </p:sldIdLst>
   <p:notesMasterIdLst>
-    <p:notesMasterId r:id="rId5"/>
+    <p:notesMasterId r:id="rId6"/>
   </p:notesMasterIdLst>
   <p:sldSz cx="12192000" cy="6858000"/>
   <p:notesSz cx="6858000" cy="12192000"/>
@@ -665,6 +666,508 @@
 </c:chartSpace>
 </file>
 
+<file path=ppt/charts/chart10.xml><?xml version="1.0" encoding="utf-8"?>
+<c:chartSpace xmlns:c="http://schemas.openxmlformats.org/drawingml/2006/chart" xmlns:a="http://schemas.openxmlformats.org/drawingml/2006/main" xmlns:r="http://schemas.openxmlformats.org/officeDocument/2006/relationships">
+  <c:date1904 val="0"/>
+  <c:roundedCorners val="1"/>
+  <c:chart>
+    <c:title>
+      <c:tx>
+        <c:rich>
+          <a:bodyPr/>
+          <a:lstStyle/>
+          <a:p>
+            <a:pPr>
+              <a:defRPr sz="1200" b="0" i="0" u="none" strike="noStrike">
+                <a:solidFill>
+                  <a:srgbClr val="16233D"/>
+                </a:solidFill>
+                <a:latin typeface="Calibri"/>
+              </a:defRPr>
+            </a:pPr>
+            <a:r>
+              <a:rPr sz="1200" b="0" i="0" u="none" strike="noStrike">
+                <a:solidFill>
+                  <a:srgbClr val="16233D"/>
+                </a:solidFill>
+                <a:latin typeface="Calibri"/>
+              </a:rPr>
+              <a:t>Tenure in years by book date (% of customers)</a:t>
+            </a:r>
+          </a:p>
+        </c:rich>
+      </c:tx>
+      <c:layout/>
+      <c:overlay val="0"/>
+    </c:title>
+    <c:autoTitleDeleted val="0"/>
+    <c:plotArea>
+      <c:layout/>
+      <c:barChart>
+        <c:barDir val="col"/>
+        <c:grouping val="percentStacked"/>
+        <c:varyColors val="0"/>
+        <c:ser>
+          <c:idx val="0"/>
+          <c:order val="0"/>
+          <c:tx>
+            <c:strRef>
+              <c:f>Sheet1!$B$1</c:f>
+              <c:strCache>
+                <c:ptCount val="1"/>
+                <c:pt idx="0">
+                  <c:v>0–1</c:v>
+                </c:pt>
+              </c:strCache>
+            </c:strRef>
+          </c:tx>
+          <c:spPr>
+            <a:solidFill>
+              <a:srgbClr val="3FB89F"/>
+            </a:solidFill>
+            <a:effectLst/>
+          </c:spPr>
+          <c:invertIfNegative val="0"/>
+          <c:dLbls>
+            <c:numFmt formatCode="0&quot;%&quot;" sourceLinked="0"/>
+            <c:txPr>
+              <a:bodyPr/>
+              <a:lstStyle/>
+              <a:p>
+                <a:pPr>
+                  <a:defRPr b="0" i="0" strike="noStrike" sz="900" u="none">
+                    <a:solidFill>
+                      <a:srgbClr val="FFFFFF"/>
+                    </a:solidFill>
+                    <a:latin typeface="Calibri"/>
+                  </a:defRPr>
+                </a:pPr>
+              </a:p>
+            </c:txPr>
+            <c:dLblPos val="ctr"/>
+            <c:showLegendKey val="0"/>
+            <c:showVal val="1"/>
+            <c:showCatName val="0"/>
+            <c:showSerName val="0"/>
+            <c:showPercent val="0"/>
+            <c:showBubbleSize val="0"/>
+            <c:showLeaderLines val="0"/>
+          </c:dLbls>
+          <c:cat>
+            <c:multiLvlStrRef>
+              <c:f>Sheet1!$A$2:$A$7</c:f>
+              <c:multiLvlStrCache>
+                <c:ptCount val="6"/>
+                <c:lvl>
+                  <c:pt idx="0">
+                    <c:v>bef 1 Aug</c:v>
+                  </c:pt>
+                  <c:pt idx="1">
+                    <c:v>1-Aug</c:v>
+                  </c:pt>
+                  <c:pt idx="2">
+                    <c:v>2-Aug</c:v>
+                  </c:pt>
+                  <c:pt idx="3">
+                    <c:v>3-Aug</c:v>
+                  </c:pt>
+                  <c:pt idx="4">
+                    <c:v>4-Aug</c:v>
+                  </c:pt>
+                  <c:pt idx="5">
+                    <c:v>5-Aug</c:v>
+                  </c:pt>
+                </c:lvl>
+              </c:multiLvlStrCache>
+            </c:multiLvlStrRef>
+          </c:cat>
+          <c:val>
+            <c:numRef>
+              <c:f>Sheet1!$B$2:$B$7</c:f>
+              <c:numCache>
+                <c:formatCode>General</c:formatCode>
+                <c:ptCount val="6"/>
+                <c:pt idx="0">
+                  <c:v>4.4</c:v>
+                </c:pt>
+                <c:pt idx="1">
+                  <c:v>11.6</c:v>
+                </c:pt>
+                <c:pt idx="2">
+                  <c:v>11.6</c:v>
+                </c:pt>
+                <c:pt idx="3">
+                  <c:v>10.9</c:v>
+                </c:pt>
+                <c:pt idx="4">
+                  <c:v>10.5</c:v>
+                </c:pt>
+                <c:pt idx="5">
+                  <c:v>9.7</c:v>
+                </c:pt>
+              </c:numCache>
+            </c:numRef>
+          </c:val>
+        </c:ser>
+        <c:ser>
+          <c:idx val="1"/>
+          <c:order val="1"/>
+          <c:tx>
+            <c:strRef>
+              <c:f>Sheet1!$C$1</c:f>
+              <c:strCache>
+                <c:ptCount val="1"/>
+                <c:pt idx="0">
+                  <c:v>2–4</c:v>
+                </c:pt>
+              </c:strCache>
+            </c:strRef>
+          </c:tx>
+          <c:spPr>
+            <a:solidFill>
+              <a:srgbClr val="1E8E86"/>
+            </a:solidFill>
+            <a:effectLst/>
+          </c:spPr>
+          <c:invertIfNegative val="0"/>
+          <c:dLbls>
+            <c:numFmt formatCode="0&quot;%&quot;" sourceLinked="0"/>
+            <c:txPr>
+              <a:bodyPr/>
+              <a:lstStyle/>
+              <a:p>
+                <a:pPr>
+                  <a:defRPr b="0" i="0" strike="noStrike" sz="900" u="none">
+                    <a:solidFill>
+                      <a:srgbClr val="FFFFFF"/>
+                    </a:solidFill>
+                    <a:latin typeface="Calibri"/>
+                  </a:defRPr>
+                </a:pPr>
+              </a:p>
+            </c:txPr>
+            <c:dLblPos val="ctr"/>
+            <c:showLegendKey val="0"/>
+            <c:showVal val="1"/>
+            <c:showCatName val="0"/>
+            <c:showSerName val="0"/>
+            <c:showPercent val="0"/>
+            <c:showBubbleSize val="0"/>
+            <c:showLeaderLines val="0"/>
+          </c:dLbls>
+          <c:cat>
+            <c:multiLvlStrRef>
+              <c:f>Sheet1!$A$2:$A$7</c:f>
+              <c:multiLvlStrCache>
+                <c:ptCount val="6"/>
+                <c:lvl>
+                  <c:pt idx="0">
+                    <c:v>bef 1 Aug</c:v>
+                  </c:pt>
+                  <c:pt idx="1">
+                    <c:v>1-Aug</c:v>
+                  </c:pt>
+                  <c:pt idx="2">
+                    <c:v>2-Aug</c:v>
+                  </c:pt>
+                  <c:pt idx="3">
+                    <c:v>3-Aug</c:v>
+                  </c:pt>
+                  <c:pt idx="4">
+                    <c:v>4-Aug</c:v>
+                  </c:pt>
+                  <c:pt idx="5">
+                    <c:v>5-Aug</c:v>
+                  </c:pt>
+                </c:lvl>
+              </c:multiLvlStrCache>
+            </c:multiLvlStrRef>
+          </c:cat>
+          <c:val>
+            <c:numRef>
+              <c:f>Sheet1!$C$2:$C$7</c:f>
+              <c:numCache>
+                <c:formatCode>General</c:formatCode>
+                <c:ptCount val="6"/>
+                <c:pt idx="0">
+                  <c:v>14.7</c:v>
+                </c:pt>
+                <c:pt idx="1">
+                  <c:v>22.7</c:v>
+                </c:pt>
+                <c:pt idx="2">
+                  <c:v>23.3</c:v>
+                </c:pt>
+                <c:pt idx="3">
+                  <c:v>23.1</c:v>
+                </c:pt>
+                <c:pt idx="4">
+                  <c:v>22.7</c:v>
+                </c:pt>
+                <c:pt idx="5">
+                  <c:v>21.9</c:v>
+                </c:pt>
+              </c:numCache>
+            </c:numRef>
+          </c:val>
+        </c:ser>
+        <c:ser>
+          <c:idx val="2"/>
+          <c:order val="2"/>
+          <c:tx>
+            <c:strRef>
+              <c:f>Sheet1!$D$1</c:f>
+              <c:strCache>
+                <c:ptCount val="1"/>
+                <c:pt idx="0">
+                  <c:v>5 or more</c:v>
+                </c:pt>
+              </c:strCache>
+            </c:strRef>
+          </c:tx>
+          <c:spPr>
+            <a:solidFill>
+              <a:srgbClr val="165A73"/>
+            </a:solidFill>
+            <a:effectLst/>
+          </c:spPr>
+          <c:invertIfNegative val="0"/>
+          <c:dLbls>
+            <c:numFmt formatCode="0&quot;%&quot;" sourceLinked="0"/>
+            <c:txPr>
+              <a:bodyPr/>
+              <a:lstStyle/>
+              <a:p>
+                <a:pPr>
+                  <a:defRPr b="0" i="0" strike="noStrike" sz="900" u="none">
+                    <a:solidFill>
+                      <a:srgbClr val="FFFFFF"/>
+                    </a:solidFill>
+                    <a:latin typeface="Calibri"/>
+                  </a:defRPr>
+                </a:pPr>
+              </a:p>
+            </c:txPr>
+            <c:dLblPos val="ctr"/>
+            <c:showLegendKey val="0"/>
+            <c:showVal val="1"/>
+            <c:showCatName val="0"/>
+            <c:showSerName val="0"/>
+            <c:showPercent val="0"/>
+            <c:showBubbleSize val="0"/>
+            <c:showLeaderLines val="0"/>
+          </c:dLbls>
+          <c:cat>
+            <c:multiLvlStrRef>
+              <c:f>Sheet1!$A$2:$A$7</c:f>
+              <c:multiLvlStrCache>
+                <c:ptCount val="6"/>
+                <c:lvl>
+                  <c:pt idx="0">
+                    <c:v>bef 1 Aug</c:v>
+                  </c:pt>
+                  <c:pt idx="1">
+                    <c:v>1-Aug</c:v>
+                  </c:pt>
+                  <c:pt idx="2">
+                    <c:v>2-Aug</c:v>
+                  </c:pt>
+                  <c:pt idx="3">
+                    <c:v>3-Aug</c:v>
+                  </c:pt>
+                  <c:pt idx="4">
+                    <c:v>4-Aug</c:v>
+                  </c:pt>
+                  <c:pt idx="5">
+                    <c:v>5-Aug</c:v>
+                  </c:pt>
+                </c:lvl>
+              </c:multiLvlStrCache>
+            </c:multiLvlStrRef>
+          </c:cat>
+          <c:val>
+            <c:numRef>
+              <c:f>Sheet1!$D$2:$D$7</c:f>
+              <c:numCache>
+                <c:formatCode>General</c:formatCode>
+                <c:ptCount val="6"/>
+                <c:pt idx="0">
+                  <c:v>80.9</c:v>
+                </c:pt>
+                <c:pt idx="1">
+                  <c:v>65.7</c:v>
+                </c:pt>
+                <c:pt idx="2">
+                  <c:v>65.1</c:v>
+                </c:pt>
+                <c:pt idx="3">
+                  <c:v>66</c:v>
+                </c:pt>
+                <c:pt idx="4">
+                  <c:v>66.8</c:v>
+                </c:pt>
+                <c:pt idx="5">
+                  <c:v>68.4</c:v>
+                </c:pt>
+              </c:numCache>
+            </c:numRef>
+          </c:val>
+        </c:ser>
+        <c:dLbls>
+          <c:numFmt formatCode="0&quot;%&quot;" sourceLinked="0"/>
+          <c:txPr>
+            <a:bodyPr/>
+            <a:lstStyle/>
+            <a:p>
+              <a:pPr>
+                <a:defRPr b="0" i="0" strike="noStrike" sz="900" u="none">
+                  <a:solidFill>
+                    <a:srgbClr val="FFFFFF"/>
+                  </a:solidFill>
+                  <a:latin typeface="Calibri"/>
+                </a:defRPr>
+              </a:pPr>
+            </a:p>
+          </c:txPr>
+          <c:dLblPos val="ctr"/>
+          <c:showLegendKey val="0"/>
+          <c:showVal val="1"/>
+          <c:showCatName val="0"/>
+          <c:showSerName val="0"/>
+          <c:showPercent val="0"/>
+          <c:showBubbleSize val="0"/>
+          <c:showLeaderLines val="0"/>
+        </c:dLbls>
+        <c:gapWidth val="45"/>
+        <c:overlap val="100"/>
+        <c:axId val="2094734554"/>
+        <c:axId val="2094734552"/>
+        <c:axId val="2094734556"/>
+      </c:barChart>
+      <c:catAx>
+        <c:axId val="2094734554"/>
+        <c:scaling>
+          <c:orientation val="minMax"/>
+        </c:scaling>
+        <c:delete val="0"/>
+        <c:axPos val="b"/>
+        <c:numFmt formatCode="General" sourceLinked="1"/>
+        <c:majorTickMark val="out"/>
+        <c:minorTickMark val="none"/>
+        <c:tickLblPos val="low"/>
+        <c:spPr>
+          <a:ln w="12700" cap="flat">
+            <a:solidFill>
+              <a:srgbClr val="888888"/>
+            </a:solidFill>
+            <a:prstDash val="solid"/>
+            <a:round/>
+          </a:ln>
+        </c:spPr>
+        <c:txPr>
+          <a:bodyPr/>
+          <a:lstStyle/>
+          <a:p>
+            <a:pPr>
+              <a:defRPr sz="1000" b="0" i="0" u="none" strike="noStrike">
+                <a:solidFill>
+                  <a:srgbClr val="16233D"/>
+                </a:solidFill>
+                <a:latin typeface="Calibri"/>
+              </a:defRPr>
+            </a:pPr>
+            <a:endParaRPr lang="en-US"/>
+          </a:p>
+        </c:txPr>
+        <c:crossAx val="2094734552"/>
+        <c:crosses val="autoZero"/>
+        <c:auto val="1"/>
+        <c:lblAlgn val="ctr"/>
+        <c:noMultiLvlLbl val="1"/>
+      </c:catAx>
+      <c:valAx>
+        <c:axId val="2094734552"/>
+        <c:scaling>
+          <c:orientation val="minMax"/>
+        </c:scaling>
+        <c:delete val="1"/>
+        <c:axPos val="l"/>
+        <c:numFmt formatCode="General" sourceLinked="0"/>
+        <c:majorTickMark val="out"/>
+        <c:minorTickMark val="none"/>
+        <c:tickLblPos val="nextTo"/>
+        <c:spPr>
+          <a:ln w="12700" cap="flat">
+            <a:solidFill>
+              <a:srgbClr val="888888"/>
+            </a:solidFill>
+            <a:prstDash val="solid"/>
+            <a:round/>
+          </a:ln>
+        </c:spPr>
+        <c:txPr>
+          <a:bodyPr/>
+          <a:lstStyle/>
+          <a:p>
+            <a:pPr>
+              <a:defRPr sz="1200" b="0" i="0" u="none" strike="noStrike">
+                <a:solidFill>
+                  <a:srgbClr val="000000"/>
+                </a:solidFill>
+                <a:latin typeface="Arial"/>
+              </a:defRPr>
+            </a:pPr>
+            <a:endParaRPr lang="en-US"/>
+          </a:p>
+        </c:txPr>
+        <c:crossAx val="2094734554"/>
+        <c:crosses val="autoZero"/>
+        <c:crossBetween val="between"/>
+      </c:valAx>
+      <c:spPr>
+        <a:noFill/>
+        <a:ln>
+          <a:noFill/>
+        </a:ln>
+        <a:effectLst/>
+      </c:spPr>
+    </c:plotArea>
+    <c:legend>
+      <c:legendPos val="b"/>
+      <c:overlay val="0"/>
+      <c:txPr>
+        <a:bodyPr/>
+        <a:lstStyle/>
+        <a:p>
+          <a:pPr>
+            <a:defRPr sz="1000">
+              <a:solidFill>
+                <a:srgbClr val="16233D"/>
+              </a:solidFill>
+              <a:latin typeface="Calibri"/>
+              <a:cs typeface="Calibri"/>
+            </a:defRPr>
+          </a:pPr>
+          <a:endParaRPr lang="en-US"/>
+        </a:p>
+      </c:txPr>
+    </c:legend>
+    <c:plotVisOnly val="1"/>
+    <c:dispBlanksAs val="span"/>
+  </c:chart>
+  <c:spPr>
+    <a:noFill/>
+    <a:ln>
+      <a:noFill/>
+    </a:ln>
+    <a:effectLst/>
+  </c:spPr>
+  <c:externalData r:id="rId1">
+    <c:autoUpdate val="0"/>
+  </c:externalData>
+</c:chartSpace>
+</file>
+
 <file path=ppt/charts/chart2.xml><?xml version="1.0" encoding="utf-8"?>
 <c:chartSpace xmlns:c="http://schemas.openxmlformats.org/drawingml/2006/chart" xmlns:a="http://schemas.openxmlformats.org/drawingml/2006/main" xmlns:r="http://schemas.openxmlformats.org/officeDocument/2006/relationships">
   <c:date1904 val="0"/>
@@ -3268,6 +3771,508 @@
                 </c:pt>
                 <c:pt idx="5">
                   <c:v>66.6</c:v>
+                </c:pt>
+              </c:numCache>
+            </c:numRef>
+          </c:val>
+        </c:ser>
+        <c:dLbls>
+          <c:numFmt formatCode="0&quot;%&quot;" sourceLinked="0"/>
+          <c:txPr>
+            <a:bodyPr/>
+            <a:lstStyle/>
+            <a:p>
+              <a:pPr>
+                <a:defRPr b="0" i="0" strike="noStrike" sz="900" u="none">
+                  <a:solidFill>
+                    <a:srgbClr val="FFFFFF"/>
+                  </a:solidFill>
+                  <a:latin typeface="Calibri"/>
+                </a:defRPr>
+              </a:pPr>
+            </a:p>
+          </c:txPr>
+          <c:dLblPos val="ctr"/>
+          <c:showLegendKey val="0"/>
+          <c:showVal val="1"/>
+          <c:showCatName val="0"/>
+          <c:showSerName val="0"/>
+          <c:showPercent val="0"/>
+          <c:showBubbleSize val="0"/>
+          <c:showLeaderLines val="0"/>
+        </c:dLbls>
+        <c:gapWidth val="45"/>
+        <c:overlap val="100"/>
+        <c:axId val="2094734554"/>
+        <c:axId val="2094734552"/>
+        <c:axId val="2094734556"/>
+      </c:barChart>
+      <c:catAx>
+        <c:axId val="2094734554"/>
+        <c:scaling>
+          <c:orientation val="minMax"/>
+        </c:scaling>
+        <c:delete val="0"/>
+        <c:axPos val="b"/>
+        <c:numFmt formatCode="General" sourceLinked="1"/>
+        <c:majorTickMark val="out"/>
+        <c:minorTickMark val="none"/>
+        <c:tickLblPos val="low"/>
+        <c:spPr>
+          <a:ln w="12700" cap="flat">
+            <a:solidFill>
+              <a:srgbClr val="888888"/>
+            </a:solidFill>
+            <a:prstDash val="solid"/>
+            <a:round/>
+          </a:ln>
+        </c:spPr>
+        <c:txPr>
+          <a:bodyPr/>
+          <a:lstStyle/>
+          <a:p>
+            <a:pPr>
+              <a:defRPr sz="1000" b="0" i="0" u="none" strike="noStrike">
+                <a:solidFill>
+                  <a:srgbClr val="16233D"/>
+                </a:solidFill>
+                <a:latin typeface="Calibri"/>
+              </a:defRPr>
+            </a:pPr>
+            <a:endParaRPr lang="en-US"/>
+          </a:p>
+        </c:txPr>
+        <c:crossAx val="2094734552"/>
+        <c:crosses val="autoZero"/>
+        <c:auto val="1"/>
+        <c:lblAlgn val="ctr"/>
+        <c:noMultiLvlLbl val="1"/>
+      </c:catAx>
+      <c:valAx>
+        <c:axId val="2094734552"/>
+        <c:scaling>
+          <c:orientation val="minMax"/>
+        </c:scaling>
+        <c:delete val="1"/>
+        <c:axPos val="l"/>
+        <c:numFmt formatCode="General" sourceLinked="0"/>
+        <c:majorTickMark val="out"/>
+        <c:minorTickMark val="none"/>
+        <c:tickLblPos val="nextTo"/>
+        <c:spPr>
+          <a:ln w="12700" cap="flat">
+            <a:solidFill>
+              <a:srgbClr val="888888"/>
+            </a:solidFill>
+            <a:prstDash val="solid"/>
+            <a:round/>
+          </a:ln>
+        </c:spPr>
+        <c:txPr>
+          <a:bodyPr/>
+          <a:lstStyle/>
+          <a:p>
+            <a:pPr>
+              <a:defRPr sz="1200" b="0" i="0" u="none" strike="noStrike">
+                <a:solidFill>
+                  <a:srgbClr val="000000"/>
+                </a:solidFill>
+                <a:latin typeface="Arial"/>
+              </a:defRPr>
+            </a:pPr>
+            <a:endParaRPr lang="en-US"/>
+          </a:p>
+        </c:txPr>
+        <c:crossAx val="2094734554"/>
+        <c:crosses val="autoZero"/>
+        <c:crossBetween val="between"/>
+      </c:valAx>
+      <c:spPr>
+        <a:noFill/>
+        <a:ln>
+          <a:noFill/>
+        </a:ln>
+        <a:effectLst/>
+      </c:spPr>
+    </c:plotArea>
+    <c:legend>
+      <c:legendPos val="b"/>
+      <c:overlay val="0"/>
+      <c:txPr>
+        <a:bodyPr/>
+        <a:lstStyle/>
+        <a:p>
+          <a:pPr>
+            <a:defRPr sz="1000">
+              <a:solidFill>
+                <a:srgbClr val="16233D"/>
+              </a:solidFill>
+              <a:latin typeface="Calibri"/>
+              <a:cs typeface="Calibri"/>
+            </a:defRPr>
+          </a:pPr>
+          <a:endParaRPr lang="en-US"/>
+        </a:p>
+      </c:txPr>
+    </c:legend>
+    <c:plotVisOnly val="1"/>
+    <c:dispBlanksAs val="span"/>
+  </c:chart>
+  <c:spPr>
+    <a:noFill/>
+    <a:ln>
+      <a:noFill/>
+    </a:ln>
+    <a:effectLst/>
+  </c:spPr>
+  <c:externalData r:id="rId1">
+    <c:autoUpdate val="0"/>
+  </c:externalData>
+</c:chartSpace>
+</file>
+
+<file path=ppt/charts/chart9.xml><?xml version="1.0" encoding="utf-8"?>
+<c:chartSpace xmlns:c="http://schemas.openxmlformats.org/drawingml/2006/chart" xmlns:a="http://schemas.openxmlformats.org/drawingml/2006/main" xmlns:r="http://schemas.openxmlformats.org/officeDocument/2006/relationships">
+  <c:date1904 val="0"/>
+  <c:roundedCorners val="1"/>
+  <c:chart>
+    <c:title>
+      <c:tx>
+        <c:rich>
+          <a:bodyPr/>
+          <a:lstStyle/>
+          <a:p>
+            <a:pPr>
+              <a:defRPr sz="1200" b="0" i="0" u="none" strike="noStrike">
+                <a:solidFill>
+                  <a:srgbClr val="16233D"/>
+                </a:solidFill>
+                <a:latin typeface="Calibri"/>
+              </a:defRPr>
+            </a:pPr>
+            <a:r>
+              <a:rPr sz="1200" b="0" i="0" u="none" strike="noStrike">
+                <a:solidFill>
+                  <a:srgbClr val="16233D"/>
+                </a:solidFill>
+                <a:latin typeface="Calibri"/>
+              </a:rPr>
+              <a:t>Charge type by book date (% of customers)</a:t>
+            </a:r>
+          </a:p>
+        </c:rich>
+      </c:tx>
+      <c:layout/>
+      <c:overlay val="0"/>
+    </c:title>
+    <c:autoTitleDeleted val="0"/>
+    <c:plotArea>
+      <c:layout/>
+      <c:barChart>
+        <c:barDir val="col"/>
+        <c:grouping val="percentStacked"/>
+        <c:varyColors val="0"/>
+        <c:ser>
+          <c:idx val="0"/>
+          <c:order val="0"/>
+          <c:tx>
+            <c:strRef>
+              <c:f>Sheet1!$B$1</c:f>
+              <c:strCache>
+                <c:ptCount val="1"/>
+                <c:pt idx="0">
+                  <c:v>FBB</c:v>
+                </c:pt>
+              </c:strCache>
+            </c:strRef>
+          </c:tx>
+          <c:spPr>
+            <a:solidFill>
+              <a:srgbClr val="3FB89F"/>
+            </a:solidFill>
+            <a:effectLst/>
+          </c:spPr>
+          <c:invertIfNegative val="0"/>
+          <c:dLbls>
+            <c:numFmt formatCode="0&quot;%&quot;" sourceLinked="0"/>
+            <c:txPr>
+              <a:bodyPr/>
+              <a:lstStyle/>
+              <a:p>
+                <a:pPr>
+                  <a:defRPr b="0" i="0" strike="noStrike" sz="900" u="none">
+                    <a:solidFill>
+                      <a:srgbClr val="FFFFFF"/>
+                    </a:solidFill>
+                    <a:latin typeface="Calibri"/>
+                  </a:defRPr>
+                </a:pPr>
+              </a:p>
+            </c:txPr>
+            <c:dLblPos val="ctr"/>
+            <c:showLegendKey val="0"/>
+            <c:showVal val="1"/>
+            <c:showCatName val="0"/>
+            <c:showSerName val="0"/>
+            <c:showPercent val="0"/>
+            <c:showBubbleSize val="0"/>
+            <c:showLeaderLines val="0"/>
+          </c:dLbls>
+          <c:cat>
+            <c:multiLvlStrRef>
+              <c:f>Sheet1!$A$2:$A$7</c:f>
+              <c:multiLvlStrCache>
+                <c:ptCount val="6"/>
+                <c:lvl>
+                  <c:pt idx="0">
+                    <c:v>bef 1 Aug</c:v>
+                  </c:pt>
+                  <c:pt idx="1">
+                    <c:v>1-Aug</c:v>
+                  </c:pt>
+                  <c:pt idx="2">
+                    <c:v>2-Aug</c:v>
+                  </c:pt>
+                  <c:pt idx="3">
+                    <c:v>3-Aug</c:v>
+                  </c:pt>
+                  <c:pt idx="4">
+                    <c:v>4-Aug</c:v>
+                  </c:pt>
+                  <c:pt idx="5">
+                    <c:v>5-Aug</c:v>
+                  </c:pt>
+                </c:lvl>
+              </c:multiLvlStrCache>
+            </c:multiLvlStrRef>
+          </c:cat>
+          <c:val>
+            <c:numRef>
+              <c:f>Sheet1!$B$2:$B$7</c:f>
+              <c:numCache>
+                <c:formatCode>General</c:formatCode>
+                <c:ptCount val="6"/>
+                <c:pt idx="0">
+                  <c:v>3.8</c:v>
+                </c:pt>
+                <c:pt idx="1">
+                  <c:v>6.9</c:v>
+                </c:pt>
+                <c:pt idx="2">
+                  <c:v>6.9</c:v>
+                </c:pt>
+                <c:pt idx="3">
+                  <c:v>7.6</c:v>
+                </c:pt>
+                <c:pt idx="4">
+                  <c:v>6.9</c:v>
+                </c:pt>
+                <c:pt idx="5">
+                  <c:v>4.9</c:v>
+                </c:pt>
+              </c:numCache>
+            </c:numRef>
+          </c:val>
+        </c:ser>
+        <c:ser>
+          <c:idx val="1"/>
+          <c:order val="1"/>
+          <c:tx>
+            <c:strRef>
+              <c:f>Sheet1!$C$1</c:f>
+              <c:strCache>
+                <c:ptCount val="1"/>
+                <c:pt idx="0">
+                  <c:v>Prepaid</c:v>
+                </c:pt>
+              </c:strCache>
+            </c:strRef>
+          </c:tx>
+          <c:spPr>
+            <a:solidFill>
+              <a:srgbClr val="1E8E86"/>
+            </a:solidFill>
+            <a:effectLst/>
+          </c:spPr>
+          <c:invertIfNegative val="0"/>
+          <c:dLbls>
+            <c:numFmt formatCode="0&quot;%&quot;" sourceLinked="0"/>
+            <c:txPr>
+              <a:bodyPr/>
+              <a:lstStyle/>
+              <a:p>
+                <a:pPr>
+                  <a:defRPr b="0" i="0" strike="noStrike" sz="900" u="none">
+                    <a:solidFill>
+                      <a:srgbClr val="FFFFFF"/>
+                    </a:solidFill>
+                    <a:latin typeface="Calibri"/>
+                  </a:defRPr>
+                </a:pPr>
+              </a:p>
+            </c:txPr>
+            <c:dLblPos val="ctr"/>
+            <c:showLegendKey val="0"/>
+            <c:showVal val="1"/>
+            <c:showCatName val="0"/>
+            <c:showSerName val="0"/>
+            <c:showPercent val="0"/>
+            <c:showBubbleSize val="0"/>
+            <c:showLeaderLines val="0"/>
+          </c:dLbls>
+          <c:cat>
+            <c:multiLvlStrRef>
+              <c:f>Sheet1!$A$2:$A$7</c:f>
+              <c:multiLvlStrCache>
+                <c:ptCount val="6"/>
+                <c:lvl>
+                  <c:pt idx="0">
+                    <c:v>bef 1 Aug</c:v>
+                  </c:pt>
+                  <c:pt idx="1">
+                    <c:v>1-Aug</c:v>
+                  </c:pt>
+                  <c:pt idx="2">
+                    <c:v>2-Aug</c:v>
+                  </c:pt>
+                  <c:pt idx="3">
+                    <c:v>3-Aug</c:v>
+                  </c:pt>
+                  <c:pt idx="4">
+                    <c:v>4-Aug</c:v>
+                  </c:pt>
+                  <c:pt idx="5">
+                    <c:v>5-Aug</c:v>
+                  </c:pt>
+                </c:lvl>
+              </c:multiLvlStrCache>
+            </c:multiLvlStrRef>
+          </c:cat>
+          <c:val>
+            <c:numRef>
+              <c:f>Sheet1!$C$2:$C$7</c:f>
+              <c:numCache>
+                <c:formatCode>General</c:formatCode>
+                <c:ptCount val="6"/>
+                <c:pt idx="0">
+                  <c:v>17.5</c:v>
+                </c:pt>
+                <c:pt idx="1">
+                  <c:v>46.4</c:v>
+                </c:pt>
+                <c:pt idx="2">
+                  <c:v>49.4</c:v>
+                </c:pt>
+                <c:pt idx="3">
+                  <c:v>47.9</c:v>
+                </c:pt>
+                <c:pt idx="4">
+                  <c:v>47.9</c:v>
+                </c:pt>
+                <c:pt idx="5">
+                  <c:v>55</c:v>
+                </c:pt>
+              </c:numCache>
+            </c:numRef>
+          </c:val>
+        </c:ser>
+        <c:ser>
+          <c:idx val="2"/>
+          <c:order val="2"/>
+          <c:tx>
+            <c:strRef>
+              <c:f>Sheet1!$D$1</c:f>
+              <c:strCache>
+                <c:ptCount val="1"/>
+                <c:pt idx="0">
+                  <c:v>Postpaid</c:v>
+                </c:pt>
+              </c:strCache>
+            </c:strRef>
+          </c:tx>
+          <c:spPr>
+            <a:solidFill>
+              <a:srgbClr val="165A73"/>
+            </a:solidFill>
+            <a:effectLst/>
+          </c:spPr>
+          <c:invertIfNegative val="0"/>
+          <c:dLbls>
+            <c:numFmt formatCode="0&quot;%&quot;" sourceLinked="0"/>
+            <c:txPr>
+              <a:bodyPr/>
+              <a:lstStyle/>
+              <a:p>
+                <a:pPr>
+                  <a:defRPr b="0" i="0" strike="noStrike" sz="900" u="none">
+                    <a:solidFill>
+                      <a:srgbClr val="FFFFFF"/>
+                    </a:solidFill>
+                    <a:latin typeface="Calibri"/>
+                  </a:defRPr>
+                </a:pPr>
+              </a:p>
+            </c:txPr>
+            <c:dLblPos val="ctr"/>
+            <c:showLegendKey val="0"/>
+            <c:showVal val="1"/>
+            <c:showCatName val="0"/>
+            <c:showSerName val="0"/>
+            <c:showPercent val="0"/>
+            <c:showBubbleSize val="0"/>
+            <c:showLeaderLines val="0"/>
+          </c:dLbls>
+          <c:cat>
+            <c:multiLvlStrRef>
+              <c:f>Sheet1!$A$2:$A$7</c:f>
+              <c:multiLvlStrCache>
+                <c:ptCount val="6"/>
+                <c:lvl>
+                  <c:pt idx="0">
+                    <c:v>bef 1 Aug</c:v>
+                  </c:pt>
+                  <c:pt idx="1">
+                    <c:v>1-Aug</c:v>
+                  </c:pt>
+                  <c:pt idx="2">
+                    <c:v>2-Aug</c:v>
+                  </c:pt>
+                  <c:pt idx="3">
+                    <c:v>3-Aug</c:v>
+                  </c:pt>
+                  <c:pt idx="4">
+                    <c:v>4-Aug</c:v>
+                  </c:pt>
+                  <c:pt idx="5">
+                    <c:v>5-Aug</c:v>
+                  </c:pt>
+                </c:lvl>
+              </c:multiLvlStrCache>
+            </c:multiLvlStrRef>
+          </c:cat>
+          <c:val>
+            <c:numRef>
+              <c:f>Sheet1!$D$2:$D$7</c:f>
+              <c:numCache>
+                <c:formatCode>General</c:formatCode>
+                <c:ptCount val="6"/>
+                <c:pt idx="0">
+                  <c:v>78.7</c:v>
+                </c:pt>
+                <c:pt idx="1">
+                  <c:v>46.7</c:v>
+                </c:pt>
+                <c:pt idx="2">
+                  <c:v>43.8</c:v>
+                </c:pt>
+                <c:pt idx="3">
+                  <c:v>44.5</c:v>
+                </c:pt>
+                <c:pt idx="4">
+                  <c:v>45.1</c:v>
+                </c:pt>
+                <c:pt idx="5">
+                  <c:v>40.1</c:v>
                 </c:pt>
               </c:numCache>
             </c:numRef>
@@ -4023,6 +5028,94 @@
             <a:fld id="{F7021451-1387-4CA6-816F-3879F97B5CBC}" type="slidenum">
               <a:rPr lang="en-US"/>
               <a:t>3</a:t>
+            </a:fld>
+            <a:endParaRPr lang="en-US"/>
+          </a:p>
+        </p:txBody>
+      </p:sp>
+    </p:spTree>
+    <p:extLst>
+      <p:ext uri="{BB962C8B-B14F-4D97-AF65-F5344CB8AC3E}">
+        <p14:creationId xmlns:p14="http://schemas.microsoft.com/office/powerpoint/2010/main" val="1024086991"/>
+      </p:ext>
+    </p:extLst>
+  </p:cSld>
+  <p:clrMapOvr>
+    <a:masterClrMapping/>
+  </p:clrMapOvr>
+</p:notes>
+</file>
+
+<file path=ppt/notesSlides/notesSlide4.xml><?xml version="1.0" encoding="utf-8"?>
+<p:notes xmlns:a="http://schemas.openxmlformats.org/drawingml/2006/main" xmlns:r="http://schemas.openxmlformats.org/officeDocument/2006/relationships" xmlns:p="http://schemas.openxmlformats.org/presentationml/2006/main">
+  <p:cSld>
+    <p:spTree>
+      <p:nvGrpSpPr>
+        <p:cNvPr id="1" name=""/>
+        <p:cNvGrpSpPr/>
+        <p:nvPr/>
+      </p:nvGrpSpPr>
+      <p:grpSpPr>
+        <a:xfrm>
+          <a:off x="0" y="0"/>
+          <a:ext cx="0" cy="0"/>
+          <a:chOff x="0" y="0"/>
+          <a:chExt cx="0" cy="0"/>
+        </a:xfrm>
+      </p:grpSpPr>
+      <p:sp>
+        <p:nvSpPr>
+          <p:cNvPr id="2" name="Slide Image Placeholder 1"/>
+          <p:cNvSpPr>
+            <a:spLocks noGrp="1" noRot="1" noChangeAspect="1"/>
+          </p:cNvSpPr>
+          <p:nvPr>
+            <p:ph type="sldImg"/>
+          </p:nvPr>
+        </p:nvSpPr>
+        <p:spPr/>
+      </p:sp>
+      <p:sp>
+        <p:nvSpPr>
+          <p:cNvPr id="3" name="Notes Placeholder 2"/>
+          <p:cNvSpPr>
+            <a:spLocks noGrp="1"/>
+          </p:cNvSpPr>
+          <p:nvPr>
+            <p:ph type="body" idx="1"/>
+          </p:nvPr>
+        </p:nvSpPr>
+        <p:spPr/>
+        <p:txBody>
+          <a:bodyPr/>
+          <a:lstStyle/>
+          <a:p>
+            <a:r>
+              <a:rPr lang="en-US" dirty="0"/>
+              <a:t>Completes the by-book-date view: charge type and tenure alongside the nano-loan flag and TRUE on slide 3. From 1 Aug onward prepaid runs 46.4, 49.4, 47.9, 47.9, 55.0 and tenure 5+ years runs 65.7, 65.1, 66.0, 66.8, 68.4 - spreads of 8.6 and 3.3 points against 9.5 for the nano-loan flag. The 5 Aug prepaid uptick coincides with the PL surge, and PL runs a higher prepaid share than DL (56.0% vs 48.8%).</a:t>
+            </a:r>
+            <a:endParaRPr lang="en-US" dirty="0"/>
+          </a:p>
+        </p:txBody>
+      </p:sp>
+      <p:sp>
+        <p:nvSpPr>
+          <p:cNvPr id="4" name="Slide Number Placeholder 3"/>
+          <p:cNvSpPr>
+            <a:spLocks noGrp="1"/>
+          </p:cNvSpPr>
+          <p:nvPr>
+            <p:ph type="sldNum" sz="quarter" idx="10"/>
+          </p:nvPr>
+        </p:nvSpPr>
+        <p:spPr/>
+        <p:txBody>
+          <a:bodyPr/>
+          <a:lstStyle/>
+          <a:p>
+            <a:fld id="{F7021451-1387-4CA6-816F-3879F97B5CBC}" type="slidenum">
+              <a:rPr lang="en-US"/>
+              <a:t>4</a:t>
             </a:fld>
             <a:endParaRPr lang="en-US"/>
           </a:p>
@@ -6433,7 +7526,417 @@
                 <a:ea typeface="Calibri" pitchFamily="34" charset="-122"/>
                 <a:cs typeface="Calibri" pitchFamily="34" charset="-120"/>
               </a:rPr>
-              <a:t>Source: Lending_2026.08.07.pptx, AIS Base Information slides. Volumes are the grand totals per book date; the two mixes combine DL and PL. 'bef 1 Aug' holds only 708 customers, so its mix is a small-sample outlier. Charge type and tenure barely move across the August dates (prepaid 46–55%, tenure 5+ years 65–68%) and are shown by loan type on the previous slide.</a:t>
+              <a:t>Source: Lending_2026.08.07.pptx, AIS Base Information slides. Volumes are the grand totals per book date; the two mixes combine DL and PL. 'bef 1 Aug' holds only 708 customers, so its mix is a small-sample outlier. Charge type and tenure move far less across the same window and are charted on the next slide.</a:t>
+            </a:r>
+            <a:endParaRPr lang="en-US" sz="900" dirty="0"/>
+          </a:p>
+        </p:txBody>
+      </p:sp>
+    </p:spTree>
+  </p:cSld>
+  <p:clrMapOvr>
+    <a:masterClrMapping/>
+  </p:clrMapOvr>
+</p:sld>
+</file>
+
+<file path=ppt/slides/slide4.xml><?xml version="1.0" encoding="utf-8"?>
+<p:sld xmlns:a="http://schemas.openxmlformats.org/drawingml/2006/main" xmlns:r="http://schemas.openxmlformats.org/officeDocument/2006/relationships" xmlns:p="http://schemas.openxmlformats.org/presentationml/2006/main">
+  <p:cSld name="Slide 4">
+    <p:bg>
+      <p:bgPr>
+        <a:solidFill>
+          <a:srgbClr val="FFFFFF"/>
+        </a:solidFill>
+      </p:bgPr>
+    </p:bg>
+    <p:spTree>
+      <p:nvGrpSpPr>
+        <p:cNvPr id="1" name=""/>
+        <p:cNvGrpSpPr/>
+        <p:nvPr/>
+      </p:nvGrpSpPr>
+      <p:grpSpPr>
+        <a:xfrm>
+          <a:off x="0" y="0"/>
+          <a:ext cx="0" cy="0"/>
+          <a:chOff x="0" y="0"/>
+          <a:chExt cx="0" cy="0"/>
+        </a:xfrm>
+      </p:grpSpPr>
+      <p:sp>
+        <p:nvSpPr>
+          <p:cNvPr id="2" name="Text 0"/>
+          <p:cNvSpPr/>
+          <p:nvPr/>
+        </p:nvSpPr>
+        <p:spPr>
+          <a:xfrm>
+            <a:off x="548640" y="329184"/>
+            <a:ext cx="11064240" cy="237744"/>
+          </a:xfrm>
+          <a:prstGeom prst="rect">
+            <a:avLst/>
+          </a:prstGeom>
+          <a:noFill/>
+          <a:ln/>
+        </p:spPr>
+        <p:txBody>
+          <a:bodyPr wrap="square" lIns="0" tIns="0" rIns="0" bIns="0" rtlCol="0" anchor="ctr"/>
+          <a:lstStyle/>
+          <a:p>
+            <a:pPr indent="0" marL="0">
+              <a:buNone/>
+            </a:pPr>
+            <a:r>
+              <a:rPr lang="en-US" sz="1150" b="1" spc="220" kern="0" dirty="0">
+                <a:solidFill>
+                  <a:srgbClr val="00A896"/>
+                </a:solidFill>
+                <a:latin typeface="Calibri" pitchFamily="34" charset="0"/>
+                <a:ea typeface="Calibri" pitchFamily="34" charset="-122"/>
+                <a:cs typeface="Calibri" pitchFamily="34" charset="-120"/>
+              </a:rPr>
+              <a:t>AIS BASE INFORMATION  ·  BY BOOK DATE</a:t>
+            </a:r>
+            <a:endParaRPr lang="en-US" sz="1150" dirty="0"/>
+          </a:p>
+        </p:txBody>
+      </p:sp>
+      <p:sp>
+        <p:nvSpPr>
+          <p:cNvPr id="3" name="Text 1"/>
+          <p:cNvSpPr/>
+          <p:nvPr/>
+        </p:nvSpPr>
+        <p:spPr>
+          <a:xfrm>
+            <a:off x="548640" y="603504"/>
+            <a:ext cx="11064240" cy="566928"/>
+          </a:xfrm>
+          <a:prstGeom prst="rect">
+            <a:avLst/>
+          </a:prstGeom>
+          <a:noFill/>
+          <a:ln/>
+        </p:spPr>
+        <p:txBody>
+          <a:bodyPr wrap="square" lIns="0" tIns="0" rIns="0" bIns="0" rtlCol="0" anchor="t"/>
+          <a:lstStyle/>
+          <a:p>
+            <a:pPr indent="0" marL="0">
+              <a:buNone/>
+            </a:pPr>
+            <a:r>
+              <a:rPr lang="en-US" sz="3200" b="1" dirty="0">
+                <a:solidFill>
+                  <a:srgbClr val="16233D"/>
+                </a:solidFill>
+                <a:latin typeface="Cambria" pitchFamily="34" charset="0"/>
+                <a:ea typeface="Cambria" pitchFamily="34" charset="-122"/>
+                <a:cs typeface="Cambria" pitchFamily="34" charset="-120"/>
+              </a:rPr>
+              <a:t>Charge type and tenure hold steady</a:t>
+            </a:r>
+            <a:endParaRPr lang="en-US" sz="3200" dirty="0"/>
+          </a:p>
+        </p:txBody>
+      </p:sp>
+      <p:sp>
+        <p:nvSpPr>
+          <p:cNvPr id="4" name="Text 2"/>
+          <p:cNvSpPr/>
+          <p:nvPr/>
+        </p:nvSpPr>
+        <p:spPr>
+          <a:xfrm>
+            <a:off x="548640" y="1097280"/>
+            <a:ext cx="11064240" cy="256032"/>
+          </a:xfrm>
+          <a:prstGeom prst="rect">
+            <a:avLst/>
+          </a:prstGeom>
+          <a:noFill/>
+          <a:ln/>
+        </p:spPr>
+        <p:txBody>
+          <a:bodyPr wrap="square" lIns="0" tIns="0" rIns="0" bIns="0" rtlCol="0" anchor="t"/>
+          <a:lstStyle/>
+          <a:p>
+            <a:pPr indent="0" marL="0">
+              <a:buNone/>
+            </a:pPr>
+            <a:r>
+              <a:rPr lang="en-US" sz="1250" dirty="0">
+                <a:solidFill>
+                  <a:srgbClr val="6B7A90"/>
+                </a:solidFill>
+                <a:latin typeface="Calibri" pitchFamily="34" charset="0"/>
+                <a:ea typeface="Calibri" pitchFamily="34" charset="-122"/>
+                <a:cs typeface="Calibri" pitchFamily="34" charset="-120"/>
+              </a:rPr>
+              <a:t>Unlike the nano-loan flag, these two barely move from 1 Aug onward — only the small pre-August cohort looks different.</a:t>
+            </a:r>
+            <a:endParaRPr lang="en-US" sz="1250" dirty="0"/>
+          </a:p>
+        </p:txBody>
+      </p:sp>
+      <p:sp>
+        <p:nvSpPr>
+          <p:cNvPr id="5" name="Shape 3"/>
+          <p:cNvSpPr/>
+          <p:nvPr/>
+        </p:nvSpPr>
+        <p:spPr>
+          <a:xfrm>
+            <a:off x="548640" y="1444752"/>
+            <a:ext cx="5440680" cy="3127248"/>
+          </a:xfrm>
+          <a:prstGeom prst="roundRect">
+            <a:avLst>
+              <a:gd name="adj" fmla="val 2632"/>
+            </a:avLst>
+          </a:prstGeom>
+          <a:solidFill>
+            <a:srgbClr val="F1F4F9"/>
+          </a:solidFill>
+          <a:ln/>
+        </p:spPr>
+      </p:sp>
+      <p:graphicFrame>
+        <p:nvGraphicFramePr>
+          <p:cNvPr id="6" name="Chart 0" descr=""/>
+          <p:cNvGraphicFramePr/>
+          <p:nvPr/>
+        </p:nvGraphicFramePr>
+        <p:xfrm>
+          <a:off x="658368" y="1536192"/>
+          <a:ext cx="5221224" cy="2944368"/>
+        </p:xfrm>
+        <a:graphic xmlns:a="http://schemas.openxmlformats.org/drawingml/2006/main">
+          <a:graphicData uri="http://schemas.openxmlformats.org/drawingml/2006/chart">
+            <c:chart xmlns:c="http://schemas.openxmlformats.org/drawingml/2006/chart" r:id="rId1"/>
+          </a:graphicData>
+        </a:graphic>
+      </p:graphicFrame>
+      <p:sp>
+        <p:nvSpPr>
+          <p:cNvPr id="7" name="Shape 4"/>
+          <p:cNvSpPr/>
+          <p:nvPr/>
+        </p:nvSpPr>
+        <p:spPr>
+          <a:xfrm>
+            <a:off x="6172200" y="1444752"/>
+            <a:ext cx="5440680" cy="3127248"/>
+          </a:xfrm>
+          <a:prstGeom prst="roundRect">
+            <a:avLst>
+              <a:gd name="adj" fmla="val 2632"/>
+            </a:avLst>
+          </a:prstGeom>
+          <a:solidFill>
+            <a:srgbClr val="F1F4F9"/>
+          </a:solidFill>
+          <a:ln/>
+        </p:spPr>
+      </p:sp>
+      <p:graphicFrame>
+        <p:nvGraphicFramePr>
+          <p:cNvPr id="8" name="Chart 1" descr=""/>
+          <p:cNvGraphicFramePr/>
+          <p:nvPr/>
+        </p:nvGraphicFramePr>
+        <p:xfrm>
+          <a:off x="6281928" y="1536192"/>
+          <a:ext cx="5221224" cy="2944368"/>
+        </p:xfrm>
+        <a:graphic xmlns:a="http://schemas.openxmlformats.org/drawingml/2006/main">
+          <a:graphicData uri="http://schemas.openxmlformats.org/drawingml/2006/chart">
+            <c:chart xmlns:c="http://schemas.openxmlformats.org/drawingml/2006/chart" r:id="rId2"/>
+          </a:graphicData>
+        </a:graphic>
+      </p:graphicFrame>
+      <p:sp>
+        <p:nvSpPr>
+          <p:cNvPr id="9" name="Shape 5"/>
+          <p:cNvSpPr/>
+          <p:nvPr/>
+        </p:nvSpPr>
+        <p:spPr>
+          <a:xfrm>
+            <a:off x="548640" y="4754880"/>
+            <a:ext cx="11064240" cy="1188720"/>
+          </a:xfrm>
+          <a:prstGeom prst="roundRect">
+            <a:avLst>
+              <a:gd name="adj" fmla="val 6923"/>
+            </a:avLst>
+          </a:prstGeom>
+          <a:solidFill>
+            <a:srgbClr val="0E1E3C"/>
+          </a:solidFill>
+          <a:ln/>
+        </p:spPr>
+      </p:sp>
+      <p:sp>
+        <p:nvSpPr>
+          <p:cNvPr id="10" name="Text 6"/>
+          <p:cNvSpPr/>
+          <p:nvPr/>
+        </p:nvSpPr>
+        <p:spPr>
+          <a:xfrm>
+            <a:off x="914400" y="4919472"/>
+            <a:ext cx="10332720" cy="237744"/>
+          </a:xfrm>
+          <a:prstGeom prst="rect">
+            <a:avLst/>
+          </a:prstGeom>
+          <a:noFill/>
+          <a:ln/>
+        </p:spPr>
+        <p:txBody>
+          <a:bodyPr wrap="square" lIns="0" tIns="0" rIns="0" bIns="0" rtlCol="0" anchor="ctr"/>
+          <a:lstStyle/>
+          <a:p>
+            <a:pPr indent="0" marL="0">
+              <a:buNone/>
+            </a:pPr>
+            <a:r>
+              <a:rPr lang="en-US" sz="1050" b="1" spc="180" kern="0" dirty="0">
+                <a:solidFill>
+                  <a:srgbClr val="5FD6BE"/>
+                </a:solidFill>
+                <a:latin typeface="Calibri" pitchFamily="34" charset="0"/>
+                <a:ea typeface="Calibri" pitchFamily="34" charset="-122"/>
+                <a:cs typeface="Calibri" pitchFamily="34" charset="-120"/>
+              </a:rPr>
+              <a:t>HOW MUCH EACH MIX MOVES, 1 AUG TO 5 AUG</a:t>
+            </a:r>
+            <a:endParaRPr lang="en-US" sz="1050" dirty="0"/>
+          </a:p>
+        </p:txBody>
+      </p:sp>
+      <p:sp>
+        <p:nvSpPr>
+          <p:cNvPr id="11" name="Text 7"/>
+          <p:cNvSpPr/>
+          <p:nvPr/>
+        </p:nvSpPr>
+        <p:spPr>
+          <a:xfrm>
+            <a:off x="914400" y="5175504"/>
+            <a:ext cx="10332720" cy="694944"/>
+          </a:xfrm>
+          <a:prstGeom prst="rect">
+            <a:avLst/>
+          </a:prstGeom>
+          <a:noFill/>
+          <a:ln/>
+        </p:spPr>
+        <p:txBody>
+          <a:bodyPr wrap="square" lIns="0" tIns="0" rIns="0" bIns="0" rtlCol="0" anchor="t"/>
+          <a:lstStyle/>
+          <a:p>
+            <a:pPr indent="0" marL="0">
+              <a:lnSpc>
+                <a:spcPts val="1600"/>
+              </a:lnSpc>
+              <a:buNone/>
+            </a:pPr>
+            <a:r>
+              <a:rPr lang="en-US" sz="1100" b="1" dirty="0">
+                <a:solidFill>
+                  <a:srgbClr val="5FD6BE"/>
+                </a:solidFill>
+                <a:latin typeface="Calibri" pitchFamily="34" charset="0"/>
+                <a:ea typeface="Calibri" pitchFamily="34" charset="-122"/>
+                <a:cs typeface="Calibri" pitchFamily="34" charset="-120"/>
+              </a:rPr>
+              <a:t>Prepaid 46–55% (8.6pt) · Tenure 5+ years 65–68% (3.3pt)</a:t>
+            </a:r>
+            <a:pPr indent="0" marL="0">
+              <a:lnSpc>
+                <a:spcPts val="1600"/>
+              </a:lnSpc>
+              <a:buNone/>
+            </a:pPr>
+            <a:r>
+              <a:rPr lang="en-US" sz="1100" dirty="0">
+                <a:solidFill>
+                  <a:srgbClr val="C3D0E2"/>
+                </a:solidFill>
+                <a:latin typeface="Calibri" pitchFamily="34" charset="0"/>
+                <a:ea typeface="Calibri" pitchFamily="34" charset="-122"/>
+                <a:cs typeface="Calibri" pitchFamily="34" charset="-120"/>
+              </a:rPr>
+              <a:t> — against the nano-loan flag's 9.5pt slide on the previous slide. Charge type drifts toward prepaid on 5 Aug, tracking the PL surge; tenure is flat throughout.</a:t>
+            </a:r>
+            <a:pPr indent="0" marL="0">
+              <a:lnSpc>
+                <a:spcPts val="1600"/>
+              </a:lnSpc>
+              <a:buNone/>
+            </a:pPr>
+            <a:endParaRPr lang="en-US" sz="1100" dirty="0"/>
+          </a:p>
+          <a:p>
+            <a:pPr indent="0" marL="0">
+              <a:lnSpc>
+                <a:spcPts val="1600"/>
+              </a:lnSpc>
+              <a:buNone/>
+            </a:pPr>
+            <a:r>
+              <a:rPr lang="en-US" sz="1100" dirty="0">
+                <a:solidFill>
+                  <a:srgbClr val="C3D0E2"/>
+                </a:solidFill>
+                <a:latin typeface="Calibri" pitchFamily="34" charset="0"/>
+                <a:ea typeface="Calibri" pitchFamily="34" charset="-122"/>
+                <a:cs typeface="Calibri" pitchFamily="34" charset="-120"/>
+              </a:rPr>
+              <a:t>The pre-1-Aug cohort is the exception — 79% postpaid, 81% long-tenured — but holds just 708 of the 70,100 customers.</a:t>
+            </a:r>
+            <a:endParaRPr lang="en-US" sz="1100" dirty="0"/>
+          </a:p>
+        </p:txBody>
+      </p:sp>
+      <p:sp>
+        <p:nvSpPr>
+          <p:cNvPr id="12" name="Text 8"/>
+          <p:cNvSpPr/>
+          <p:nvPr/>
+        </p:nvSpPr>
+        <p:spPr>
+          <a:xfrm>
+            <a:off x="548640" y="6089904"/>
+            <a:ext cx="11064240" cy="512064"/>
+          </a:xfrm>
+          <a:prstGeom prst="rect">
+            <a:avLst/>
+          </a:prstGeom>
+          <a:noFill/>
+          <a:ln/>
+        </p:spPr>
+        <p:txBody>
+          <a:bodyPr wrap="square" lIns="0" tIns="0" rIns="0" bIns="0" rtlCol="0" anchor="ctr"/>
+          <a:lstStyle/>
+          <a:p>
+            <a:pPr indent="0" marL="0">
+              <a:buNone/>
+            </a:pPr>
+            <a:r>
+              <a:rPr lang="en-US" sz="900" i="1" dirty="0">
+                <a:solidFill>
+                  <a:srgbClr val="6B7A90"/>
+                </a:solidFill>
+                <a:latin typeface="Calibri" pitchFamily="34" charset="0"/>
+                <a:ea typeface="Calibri" pitchFamily="34" charset="-122"/>
+                <a:cs typeface="Calibri" pitchFamily="34" charset="-120"/>
+              </a:rPr>
+              <a:t>Source: Lending_2026.08.07.pptx, the charge type and tenure AIS Base Information slides, DL and PL combined and aggregated to each book date. Percentages are computed from the deck's own counts; each date column sums to that date's grand total, and the six together sum to 70,100.</a:t>
             </a:r>
             <a:endParaRPr lang="en-US" sz="900" dirty="0"/>
           </a:p>

</xml_diff>